<commit_message>
Presentation: drop the two backup slides (22 slides)
Removes the "results by source" and "system architecture" backup slides
and the backup-slides note on the contents slide, matching the copy in
the submission package.

Co-Authored-By: Claude Opus 5.5 <noreply@anthropic.com>
</commit_message>
<xml_diff>
--- a/docs/Khmer_Speech_to_Subtitles_Final.pptx
+++ b/docs/Khmer_Speech_to_Subtitles_Final.pptx
@@ -5,7 +5,7 @@
     <p:sldMasterId id="2147483648" r:id="rId1"/>
   </p:sldMasterIdLst>
   <p:notesMasterIdLst>
-    <p:notesMasterId r:id="rId26"/>
+    <p:notesMasterId r:id="rId24"/>
   </p:notesMasterIdLst>
   <p:sldIdLst>
     <p:sldId id="256" r:id="rId2"/>
@@ -29,9 +29,7 @@
     <p:sldId id="274" r:id="rId20"/>
     <p:sldId id="275" r:id="rId21"/>
     <p:sldId id="276" r:id="rId22"/>
-    <p:sldId id="277" r:id="rId23"/>
-    <p:sldId id="278" r:id="rId24"/>
-    <p:sldId id="279" r:id="rId25"/>
+    <p:sldId id="279" r:id="rId23"/>
   </p:sldIdLst>
   <p:sldSz cx="12192000" cy="6858000"/>
   <p:notesSz cx="6858000" cy="12192000"/>
@@ -173,8 +171,6 @@
         </p14:section>
         <p14:section name="Backup" id="{A2CEA4C7-9BCA-051B-F840-3352AFD019CE}">
           <p14:sldIdLst>
-            <p14:sldId id="277"/>
-            <p14:sldId id="278"/>
             <p14:sldId id="279"/>
           </p14:sldIdLst>
         </p14:section>
@@ -185,6 +181,41 @@
     </p:ext>
   </p:extLst>
 </p:presentation>
+</file>
+
+<file path=ppt/changesInfos/changesInfo1.xml><?xml version="1.0" encoding="utf-8"?>
+<pc:chgInfo xmlns:a="http://schemas.openxmlformats.org/drawingml/2006/main" xmlns:r="http://schemas.openxmlformats.org/officeDocument/2006/relationships" xmlns:ac="http://schemas.microsoft.com/office/drawing/2013/main/command" xmlns:pc="http://schemas.microsoft.com/office/powerpoint/2013/main/command">
+  <pc:docChgLst>
+    <pc:chgData name="Reaksmey Sam" userId="9137b61491dfaff7" providerId="LiveId" clId="{5097C3A0-E173-4DCE-88C4-4D44B638932B}"/>
+    <pc:docChg chg="custSel delSld modSld modSection">
+      <pc:chgData name="Reaksmey Sam" userId="9137b61491dfaff7" providerId="LiveId" clId="{5097C3A0-E173-4DCE-88C4-4D44B638932B}" dt="2026-10-09T13:57:33.279" v="3" actId="47"/>
+      <pc:docMkLst>
+        <pc:docMk/>
+      </pc:docMkLst>
+      <pc:sldChg chg="addSp delSp modSp mod">
+        <pc:chgData name="Reaksmey Sam" userId="9137b61491dfaff7" providerId="LiveId" clId="{5097C3A0-E173-4DCE-88C4-4D44B638932B}" dt="2026-10-05T08:46:46.092" v="2" actId="478"/>
+        <pc:sldMkLst>
+          <pc:docMk/>
+          <pc:sldMk cId="0" sldId="257"/>
+        </pc:sldMkLst>
+      </pc:sldChg>
+      <pc:sldChg chg="del">
+        <pc:chgData name="Reaksmey Sam" userId="9137b61491dfaff7" providerId="LiveId" clId="{5097C3A0-E173-4DCE-88C4-4D44B638932B}" dt="2026-10-09T13:57:33.279" v="3" actId="47"/>
+        <pc:sldMkLst>
+          <pc:docMk/>
+          <pc:sldMk cId="0" sldId="277"/>
+        </pc:sldMkLst>
+      </pc:sldChg>
+      <pc:sldChg chg="del">
+        <pc:chgData name="Reaksmey Sam" userId="9137b61491dfaff7" providerId="LiveId" clId="{5097C3A0-E173-4DCE-88C4-4D44B638932B}" dt="2026-10-09T13:57:33.279" v="3" actId="47"/>
+        <pc:sldMkLst>
+          <pc:docMk/>
+          <pc:sldMk cId="0" sldId="278"/>
+        </pc:sldMkLst>
+      </pc:sldChg>
+    </pc:docChg>
+  </pc:docChgLst>
+</pc:chgInfo>
 </file>
 
 <file path=ppt/charts/chart1.xml><?xml version="1.0" encoding="utf-8"?>
@@ -254,12 +285,6 @@
             <c:idx val="0"/>
             <c:invertIfNegative val="0"/>
             <c:bubble3D val="0"/>
-            <c:spPr>
-              <a:solidFill>
-                <a:srgbClr val="B5473A"/>
-              </a:solidFill>
-              <a:effectLst/>
-            </c:spPr>
             <c:extLst>
               <c:ext xmlns:c16="http://schemas.microsoft.com/office/drawing/2014/chart" uri="{C3380CC4-5D6E-409C-BE32-E72D297353CC}">
                 <c16:uniqueId val="{00000001-2BFC-460B-81AF-636FAF05CE77}"/>
@@ -2236,7 +2261,7 @@
           <a:p>
             <a:r>
               <a:rPr lang="en-US" dirty="0"/>
-              <a:t>Broken down by source. Seeing many voices made our model better even on the single speaker the ablation was trained on. We expected single words from kheng.info to be hardest, but the hardest is km-speech-corpus: very short clips cut from the middle of sentences. It makes up two thirds of the test set, which explains why the in-domain test score is worse than the unseen-speaker score.</a:t>
+              <a:t>All dataset, model and code links. Licenses are recorded in src/config.py. Two sources are research-use only, so the combined training set is not redistributed.</a:t>
             </a:r>
           </a:p>
         </p:txBody>
@@ -2259,180 +2284,6 @@
             <a:fld id="{F7021451-1387-4CA6-816F-3879F97B5CBC}" type="slidenum">
               <a:rPr lang="en-US"/>
               <a:t>22</a:t>
-            </a:fld>
-            <a:endParaRPr lang="en-US"/>
-          </a:p>
-        </p:txBody>
-      </p:sp>
-    </p:spTree>
-    <p:extLst>
-      <p:ext uri="{BB962C8B-B14F-4D97-AF65-F5344CB8AC3E}">
-        <p14:creationId xmlns:p14="http://schemas.microsoft.com/office/powerpoint/2010/main" val="1024086991"/>
-      </p:ext>
-    </p:extLst>
-  </p:cSld>
-  <p:clrMapOvr>
-    <a:masterClrMapping/>
-  </p:clrMapOvr>
-</p:notes>
-</file>
-
-<file path=ppt/notesSlides/notesSlide23.xml><?xml version="1.0" encoding="utf-8"?>
-<p:notes xmlns:a="http://schemas.openxmlformats.org/drawingml/2006/main" xmlns:r="http://schemas.openxmlformats.org/officeDocument/2006/relationships" xmlns:p="http://schemas.openxmlformats.org/presentationml/2006/main">
-  <p:cSld>
-    <p:spTree>
-      <p:nvGrpSpPr>
-        <p:cNvPr id="1" name=""/>
-        <p:cNvGrpSpPr/>
-        <p:nvPr/>
-      </p:nvGrpSpPr>
-      <p:grpSpPr>
-        <a:xfrm>
-          <a:off x="0" y="0"/>
-          <a:ext cx="0" cy="0"/>
-          <a:chOff x="0" y="0"/>
-          <a:chExt cx="0" cy="0"/>
-        </a:xfrm>
-      </p:grpSpPr>
-      <p:sp>
-        <p:nvSpPr>
-          <p:cNvPr id="2" name="Slide Image Placeholder 1"/>
-          <p:cNvSpPr>
-            <a:spLocks noGrp="1" noRot="1" noChangeAspect="1"/>
-          </p:cNvSpPr>
-          <p:nvPr>
-            <p:ph type="sldImg"/>
-          </p:nvPr>
-        </p:nvSpPr>
-        <p:spPr/>
-      </p:sp>
-      <p:sp>
-        <p:nvSpPr>
-          <p:cNvPr id="3" name="Notes Placeholder 2"/>
-          <p:cNvSpPr>
-            <a:spLocks noGrp="1"/>
-          </p:cNvSpPr>
-          <p:nvPr>
-            <p:ph type="body" idx="1"/>
-          </p:nvPr>
-        </p:nvSpPr>
-        <p:spPr/>
-        <p:txBody>
-          <a:bodyPr/>
-          <a:lstStyle/>
-          <a:p>
-            <a:r>
-              <a:rPr lang="en-US" dirty="0"/>
-              <a:t>Four steps per video. The interesting one is splitting: Whisper normally takes 30-second windows, but Khmer script uses so many tokens that 30 seconds of speech does not fit in the decoder's 448-token limit. We cut at pauses so words are not split, into chunks of at most 10 seconds. Batching 8 chunks per call made transcription about 2.5 times faster on a laptop GPU.</a:t>
-            </a:r>
-          </a:p>
-        </p:txBody>
-      </p:sp>
-      <p:sp>
-        <p:nvSpPr>
-          <p:cNvPr id="4" name="Slide Number Placeholder 3"/>
-          <p:cNvSpPr>
-            <a:spLocks noGrp="1"/>
-          </p:cNvSpPr>
-          <p:nvPr>
-            <p:ph type="sldNum" sz="quarter" idx="10"/>
-          </p:nvPr>
-        </p:nvSpPr>
-        <p:spPr/>
-        <p:txBody>
-          <a:bodyPr/>
-          <a:lstStyle/>
-          <a:p>
-            <a:fld id="{F7021451-1387-4CA6-816F-3879F97B5CBC}" type="slidenum">
-              <a:rPr lang="en-US"/>
-              <a:t>23</a:t>
-            </a:fld>
-            <a:endParaRPr lang="en-US"/>
-          </a:p>
-        </p:txBody>
-      </p:sp>
-    </p:spTree>
-    <p:extLst>
-      <p:ext uri="{BB962C8B-B14F-4D97-AF65-F5344CB8AC3E}">
-        <p14:creationId xmlns:p14="http://schemas.microsoft.com/office/powerpoint/2010/main" val="1024086991"/>
-      </p:ext>
-    </p:extLst>
-  </p:cSld>
-  <p:clrMapOvr>
-    <a:masterClrMapping/>
-  </p:clrMapOvr>
-</p:notes>
-</file>
-
-<file path=ppt/notesSlides/notesSlide24.xml><?xml version="1.0" encoding="utf-8"?>
-<p:notes xmlns:a="http://schemas.openxmlformats.org/drawingml/2006/main" xmlns:r="http://schemas.openxmlformats.org/officeDocument/2006/relationships" xmlns:p="http://schemas.openxmlformats.org/presentationml/2006/main">
-  <p:cSld>
-    <p:spTree>
-      <p:nvGrpSpPr>
-        <p:cNvPr id="1" name=""/>
-        <p:cNvGrpSpPr/>
-        <p:nvPr/>
-      </p:nvGrpSpPr>
-      <p:grpSpPr>
-        <a:xfrm>
-          <a:off x="0" y="0"/>
-          <a:ext cx="0" cy="0"/>
-          <a:chOff x="0" y="0"/>
-          <a:chExt cx="0" cy="0"/>
-        </a:xfrm>
-      </p:grpSpPr>
-      <p:sp>
-        <p:nvSpPr>
-          <p:cNvPr id="2" name="Slide Image Placeholder 1"/>
-          <p:cNvSpPr>
-            <a:spLocks noGrp="1" noRot="1" noChangeAspect="1"/>
-          </p:cNvSpPr>
-          <p:nvPr>
-            <p:ph type="sldImg"/>
-          </p:nvPr>
-        </p:nvSpPr>
-        <p:spPr/>
-      </p:sp>
-      <p:sp>
-        <p:nvSpPr>
-          <p:cNvPr id="3" name="Notes Placeholder 2"/>
-          <p:cNvSpPr>
-            <a:spLocks noGrp="1"/>
-          </p:cNvSpPr>
-          <p:nvPr>
-            <p:ph type="body" idx="1"/>
-          </p:nvPr>
-        </p:nvSpPr>
-        <p:spPr/>
-        <p:txBody>
-          <a:bodyPr/>
-          <a:lstStyle/>
-          <a:p>
-            <a:r>
-              <a:rPr lang="en-US" dirty="0"/>
-              <a:t>All dataset, model and code links. Licenses are recorded in src/config.py. Two sources are research-use only, so the combined training set is not redistributed.</a:t>
-            </a:r>
-          </a:p>
-        </p:txBody>
-      </p:sp>
-      <p:sp>
-        <p:nvSpPr>
-          <p:cNvPr id="4" name="Slide Number Placeholder 3"/>
-          <p:cNvSpPr>
-            <a:spLocks noGrp="1"/>
-          </p:cNvSpPr>
-          <p:nvPr>
-            <p:ph type="sldNum" sz="quarter" idx="10"/>
-          </p:nvPr>
-        </p:nvSpPr>
-        <p:spPr/>
-        <p:txBody>
-          <a:bodyPr/>
-          <a:lstStyle/>
-          <a:p>
-            <a:fld id="{F7021451-1387-4CA6-816F-3879F97B5CBC}" type="slidenum">
-              <a:rPr lang="en-US"/>
-              <a:t>24</a:t>
             </a:fld>
             <a:endParaRPr lang="en-US"/>
           </a:p>
@@ -19250,46 +19101,6 @@
       </p:grpSpPr>
       <p:sp>
         <p:nvSpPr>
-          <p:cNvPr id="2" name="Text 0"/>
-          <p:cNvSpPr>
-            <a:spLocks noGrp="1"/>
-          </p:cNvSpPr>
-          <p:nvPr>
-            <p:ph type="body" idx="100" hasCustomPrompt="1"/>
-          </p:nvPr>
-        </p:nvSpPr>
-        <p:spPr>
-          <a:xfrm>
-            <a:off x="548640" y="384048"/>
-            <a:ext cx="11091672" cy="292608"/>
-          </a:xfrm>
-          <a:prstGeom prst="rect">
-            <a:avLst/>
-          </a:prstGeom>
-          <a:noFill/>
-          <a:ln/>
-        </p:spPr>
-        <p:txBody>
-          <a:bodyPr wrap="square" lIns="0" tIns="0" rIns="0" bIns="0" rtlCol="0" anchor="t"/>
-          <a:lstStyle/>
-          <a:p>
-            <a:pPr marL="0" indent="0">
-              <a:buNone/>
-            </a:pPr>
-            <a:r>
-              <a:rPr lang="en-US" sz="1400" b="1" dirty="0">
-                <a:solidFill>
-                  <a:schemeClr val="accent3"/>
-                </a:solidFill>
-              </a:rPr>
-              <a:t>Overview</a:t>
-            </a:r>
-            <a:endParaRPr lang="en-US" sz="1400" dirty="0"/>
-          </a:p>
-        </p:txBody>
-      </p:sp>
-      <p:sp>
-        <p:nvSpPr>
           <p:cNvPr id="3" name="Text 0"/>
           <p:cNvSpPr>
             <a:spLocks noGrp="1"/>
@@ -20768,42 +20579,6 @@
               <a:t>Conclusion and future work</a:t>
             </a:r>
             <a:endParaRPr lang="en-US" sz="1600" dirty="0"/>
-          </a:p>
-        </p:txBody>
-      </p:sp>
-      <p:sp>
-        <p:nvSpPr>
-          <p:cNvPr id="44" name="Text 42"/>
-          <p:cNvSpPr txBox="1"/>
-          <p:nvPr/>
-        </p:nvSpPr>
-        <p:spPr>
-          <a:xfrm>
-            <a:off x="548640" y="5897880"/>
-            <a:ext cx="11091672" cy="274320"/>
-          </a:xfrm>
-          <a:prstGeom prst="rect">
-            <a:avLst/>
-          </a:prstGeom>
-          <a:noFill/>
-          <a:ln/>
-        </p:spPr>
-        <p:txBody>
-          <a:bodyPr wrap="square" lIns="0" tIns="0" rIns="0" bIns="0" rtlCol="0" anchor="t"/>
-          <a:lstStyle/>
-          <a:p>
-            <a:pPr marL="0" indent="0">
-              <a:buNone/>
-            </a:pPr>
-            <a:r>
-              <a:rPr lang="en-US" sz="1200" i="1" dirty="0">
-                <a:solidFill>
-                  <a:schemeClr val="accent5"/>
-                </a:solidFill>
-              </a:rPr>
-              <a:t>Backup slides after “Thank you”: results by source, back-end details, references.</a:t>
-            </a:r>
-            <a:endParaRPr lang="en-US" sz="1200" dirty="0"/>
           </a:p>
         </p:txBody>
       </p:sp>
@@ -22255,2828 +22030,6 @@
 
 <file path=ppt/slides/slide22.xml><?xml version="1.0" encoding="utf-8"?>
 <p:sld xmlns:a="http://schemas.openxmlformats.org/drawingml/2006/main" xmlns:r="http://schemas.openxmlformats.org/officeDocument/2006/relationships" xmlns:p="http://schemas.openxmlformats.org/presentationml/2006/main">
-  <p:cSld name="Slide 22">
-    <p:spTree>
-      <p:nvGrpSpPr>
-        <p:cNvPr id="1" name=""/>
-        <p:cNvGrpSpPr/>
-        <p:nvPr/>
-      </p:nvGrpSpPr>
-      <p:grpSpPr>
-        <a:xfrm>
-          <a:off x="0" y="0"/>
-          <a:ext cx="0" cy="0"/>
-          <a:chOff x="0" y="0"/>
-          <a:chExt cx="0" cy="0"/>
-        </a:xfrm>
-      </p:grpSpPr>
-      <p:sp>
-        <p:nvSpPr>
-          <p:cNvPr id="2" name="Text 0"/>
-          <p:cNvSpPr>
-            <a:spLocks noGrp="1"/>
-          </p:cNvSpPr>
-          <p:nvPr>
-            <p:ph type="body" idx="100" hasCustomPrompt="1"/>
-          </p:nvPr>
-        </p:nvSpPr>
-        <p:spPr>
-          <a:xfrm>
-            <a:off x="548640" y="384048"/>
-            <a:ext cx="11091672" cy="292608"/>
-          </a:xfrm>
-          <a:prstGeom prst="rect">
-            <a:avLst/>
-          </a:prstGeom>
-          <a:noFill/>
-          <a:ln/>
-        </p:spPr>
-        <p:txBody>
-          <a:bodyPr wrap="square" lIns="0" tIns="0" rIns="0" bIns="0" rtlCol="0" anchor="t"/>
-          <a:lstStyle/>
-          <a:p>
-            <a:pPr marL="0" indent="0">
-              <a:buNone/>
-            </a:pPr>
-            <a:r>
-              <a:rPr lang="en-US" sz="1400" b="1" dirty="0">
-                <a:solidFill>
-                  <a:schemeClr val="accent3"/>
-                </a:solidFill>
-              </a:rPr>
-              <a:t>Backup: results by source</a:t>
-            </a:r>
-            <a:endParaRPr lang="en-US" sz="1400" dirty="0"/>
-          </a:p>
-        </p:txBody>
-      </p:sp>
-      <p:sp>
-        <p:nvSpPr>
-          <p:cNvPr id="3" name="Text 0"/>
-          <p:cNvSpPr>
-            <a:spLocks noGrp="1"/>
-          </p:cNvSpPr>
-          <p:nvPr>
-            <p:ph type="title" idx="101" hasCustomPrompt="1"/>
-          </p:nvPr>
-        </p:nvSpPr>
-        <p:spPr>
-          <a:xfrm>
-            <a:off x="548640" y="713232"/>
-            <a:ext cx="11091672" cy="685800"/>
-          </a:xfrm>
-          <a:prstGeom prst="rect">
-            <a:avLst/>
-          </a:prstGeom>
-          <a:noFill/>
-          <a:ln/>
-        </p:spPr>
-        <p:txBody>
-          <a:bodyPr wrap="square" lIns="0" tIns="0" rIns="0" bIns="0" rtlCol="0" anchor="t"/>
-          <a:lstStyle/>
-          <a:p>
-            <a:pPr marL="0" indent="0" algn="l">
-              <a:buNone/>
-            </a:pPr>
-            <a:r>
-              <a:rPr lang="en-US" sz="3200" b="1" dirty="0">
-                <a:solidFill>
-                  <a:schemeClr val="tx2"/>
-                </a:solidFill>
-                <a:latin typeface="Calibri" pitchFamily="34" charset="0"/>
-                <a:ea typeface="Calibri" pitchFamily="34" charset="-122"/>
-                <a:cs typeface="Calibri" pitchFamily="34" charset="-120"/>
-              </a:rPr>
-              <a:t>Best on </a:t>
-            </a:r>
-            <a:r>
-              <a:rPr lang="en-US" sz="3200" b="1" dirty="0">
-                <a:solidFill>
-                  <a:schemeClr val="accent3"/>
-                </a:solidFill>
-                <a:latin typeface="Calibri" pitchFamily="34" charset="0"/>
-                <a:ea typeface="Calibri" pitchFamily="34" charset="-122"/>
-                <a:cs typeface="Calibri" pitchFamily="34" charset="-120"/>
-              </a:rPr>
-              <a:t>every source</a:t>
-            </a:r>
-            <a:r>
-              <a:rPr lang="en-US" sz="3200" b="1" dirty="0">
-                <a:solidFill>
-                  <a:schemeClr val="tx2"/>
-                </a:solidFill>
-                <a:latin typeface="Calibri" pitchFamily="34" charset="0"/>
-                <a:ea typeface="Calibri" pitchFamily="34" charset="-122"/>
-                <a:cs typeface="Calibri" pitchFamily="34" charset="-120"/>
-              </a:rPr>
-              <a:t>, even the ablation's own</a:t>
-            </a:r>
-            <a:endParaRPr lang="en-US" sz="3200" dirty="0"/>
-          </a:p>
-        </p:txBody>
-      </p:sp>
-      <p:graphicFrame>
-        <p:nvGraphicFramePr>
-          <p:cNvPr id="23" name="results by source table"/>
-          <p:cNvGraphicFramePr>
-            <a:graphicFrameLocks noGrp="1"/>
-          </p:cNvGraphicFramePr>
-          <p:nvPr>
-            <p:extLst>
-              <p:ext uri="{D42A27DB-BD31-4B8C-83A1-F6EECF244321}">
-                <p14:modId xmlns:p14="http://schemas.microsoft.com/office/powerpoint/2010/main" val="1579011935"/>
-              </p:ext>
-            </p:extLst>
-          </p:nvPr>
-        </p:nvGraphicFramePr>
-        <p:xfrm>
-          <a:off x="548640" y="1783080"/>
-          <a:ext cx="7040880" cy="914400"/>
-        </p:xfrm>
-        <a:graphic>
-          <a:graphicData uri="http://schemas.openxmlformats.org/drawingml/2006/table">
-            <a:tbl>
-              <a:tblPr/>
-              <a:tblGrid>
-                <a:gridCol w="2514600">
-                  <a:extLst>
-                    <a:ext uri="{9D8B030D-6E8A-4147-A177-3AD203B41FA5}">
-                      <a16:colId xmlns:a16="http://schemas.microsoft.com/office/drawing/2014/main" val="20000"/>
-                    </a:ext>
-                  </a:extLst>
-                </a:gridCol>
-                <a:gridCol w="777240">
-                  <a:extLst>
-                    <a:ext uri="{9D8B030D-6E8A-4147-A177-3AD203B41FA5}">
-                      <a16:colId xmlns:a16="http://schemas.microsoft.com/office/drawing/2014/main" val="20001"/>
-                    </a:ext>
-                  </a:extLst>
-                </a:gridCol>
-                <a:gridCol w="1280160">
-                  <a:extLst>
-                    <a:ext uri="{9D8B030D-6E8A-4147-A177-3AD203B41FA5}">
-                      <a16:colId xmlns:a16="http://schemas.microsoft.com/office/drawing/2014/main" val="20002"/>
-                    </a:ext>
-                  </a:extLst>
-                </a:gridCol>
-                <a:gridCol w="1234440">
-                  <a:extLst>
-                    <a:ext uri="{9D8B030D-6E8A-4147-A177-3AD203B41FA5}">
-                      <a16:colId xmlns:a16="http://schemas.microsoft.com/office/drawing/2014/main" val="20003"/>
-                    </a:ext>
-                  </a:extLst>
-                </a:gridCol>
-                <a:gridCol w="1234440">
-                  <a:extLst>
-                    <a:ext uri="{9D8B030D-6E8A-4147-A177-3AD203B41FA5}">
-                      <a16:colId xmlns:a16="http://schemas.microsoft.com/office/drawing/2014/main" val="20004"/>
-                    </a:ext>
-                  </a:extLst>
-                </a:gridCol>
-              </a:tblGrid>
-              <a:tr h="566928">
-                <a:tc>
-                  <a:txBody>
-                    <a:bodyPr/>
-                    <a:lstStyle/>
-                    <a:p>
-                      <a:pPr marL="0" indent="0" algn="l">
-                        <a:buNone/>
-                      </a:pPr>
-                      <a:r>
-                        <a:rPr lang="en-US" sz="1500" b="1" dirty="0">
-                          <a:solidFill>
-                            <a:schemeClr val="bg1"/>
-                          </a:solidFill>
-                        </a:rPr>
-                        <a:t>Source (test split)</a:t>
-                      </a:r>
-                      <a:endParaRPr lang="en-US" sz="1500" dirty="0"/>
-                    </a:p>
-                  </a:txBody>
-                  <a:tcPr marL="109728" marT="0" marB="0" anchor="ctr">
-                    <a:lnL w="0" cap="flat" cmpd="sng" algn="ctr">
-                      <a:noFill/>
-                    </a:lnL>
-                    <a:lnR w="0" cap="flat" cmpd="sng" algn="ctr">
-                      <a:noFill/>
-                    </a:lnR>
-                    <a:lnT w="0" cap="flat" cmpd="sng" algn="ctr">
-                      <a:noFill/>
-                    </a:lnT>
-                    <a:lnB w="0" cap="flat" cmpd="sng" algn="ctr">
-                      <a:noFill/>
-                    </a:lnB>
-                    <a:solidFill>
-                      <a:schemeClr val="tx2"/>
-                    </a:solidFill>
-                  </a:tcPr>
-                </a:tc>
-                <a:tc>
-                  <a:txBody>
-                    <a:bodyPr/>
-                    <a:lstStyle/>
-                    <a:p>
-                      <a:pPr marL="0" indent="0" algn="ctr">
-                        <a:buNone/>
-                      </a:pPr>
-                      <a:r>
-                        <a:rPr lang="en-US" sz="1500" b="1" dirty="0">
-                          <a:solidFill>
-                            <a:schemeClr val="bg1"/>
-                          </a:solidFill>
-                        </a:rPr>
-                        <a:t>Clips</a:t>
-                      </a:r>
-                      <a:endParaRPr lang="en-US" sz="1500" dirty="0"/>
-                    </a:p>
-                  </a:txBody>
-                  <a:tcPr marL="109728" marT="0" marB="0" anchor="ctr">
-                    <a:lnL w="0" cap="flat" cmpd="sng" algn="ctr">
-                      <a:noFill/>
-                    </a:lnL>
-                    <a:lnR w="0" cap="flat" cmpd="sng" algn="ctr">
-                      <a:noFill/>
-                    </a:lnR>
-                    <a:lnT w="0" cap="flat" cmpd="sng" algn="ctr">
-                      <a:noFill/>
-                    </a:lnT>
-                    <a:lnB w="0" cap="flat" cmpd="sng" algn="ctr">
-                      <a:noFill/>
-                    </a:lnB>
-                    <a:solidFill>
-                      <a:schemeClr val="tx2"/>
-                    </a:solidFill>
-                  </a:tcPr>
-                </a:tc>
-                <a:tc>
-                  <a:txBody>
-                    <a:bodyPr/>
-                    <a:lstStyle/>
-                    <a:p>
-                      <a:pPr marL="0" indent="0" algn="ctr">
-                        <a:buNone/>
-                      </a:pPr>
-                      <a:r>
-                        <a:rPr lang="en-US" sz="1500" b="1" dirty="0">
-                          <a:solidFill>
-                            <a:schemeClr val="bg1"/>
-                          </a:solidFill>
-                        </a:rPr>
-                        <a:t>Baseline</a:t>
-                      </a:r>
-                      <a:endParaRPr lang="en-US" sz="1500" dirty="0"/>
-                    </a:p>
-                  </a:txBody>
-                  <a:tcPr marL="109728" marT="0" marB="0" anchor="ctr">
-                    <a:lnL w="0" cap="flat" cmpd="sng" algn="ctr">
-                      <a:noFill/>
-                    </a:lnL>
-                    <a:lnR w="0" cap="flat" cmpd="sng" algn="ctr">
-                      <a:noFill/>
-                    </a:lnR>
-                    <a:lnT w="0" cap="flat" cmpd="sng" algn="ctr">
-                      <a:noFill/>
-                    </a:lnT>
-                    <a:lnB w="0" cap="flat" cmpd="sng" algn="ctr">
-                      <a:noFill/>
-                    </a:lnB>
-                    <a:solidFill>
-                      <a:schemeClr val="accent4"/>
-                    </a:solidFill>
-                  </a:tcPr>
-                </a:tc>
-                <a:tc>
-                  <a:txBody>
-                    <a:bodyPr/>
-                    <a:lstStyle/>
-                    <a:p>
-                      <a:pPr marL="0" indent="0" algn="ctr">
-                        <a:buNone/>
-                      </a:pPr>
-                      <a:r>
-                        <a:rPr lang="en-US" sz="1500" b="1" dirty="0">
-                          <a:solidFill>
-                            <a:schemeClr val="bg1"/>
-                          </a:solidFill>
-                        </a:rPr>
-                        <a:t>Ablation</a:t>
-                      </a:r>
-                      <a:endParaRPr lang="en-US" sz="1500" dirty="0"/>
-                    </a:p>
-                  </a:txBody>
-                  <a:tcPr marL="109728" marT="0" marB="0" anchor="ctr">
-                    <a:lnL w="0" cap="flat" cmpd="sng" algn="ctr">
-                      <a:noFill/>
-                    </a:lnL>
-                    <a:lnR w="0" cap="flat" cmpd="sng" algn="ctr">
-                      <a:noFill/>
-                    </a:lnR>
-                    <a:lnT w="0" cap="flat" cmpd="sng" algn="ctr">
-                      <a:noFill/>
-                    </a:lnT>
-                    <a:lnB w="0" cap="flat" cmpd="sng" algn="ctr">
-                      <a:noFill/>
-                    </a:lnB>
-                    <a:solidFill>
-                      <a:schemeClr val="accent2"/>
-                    </a:solidFill>
-                  </a:tcPr>
-                </a:tc>
-                <a:tc>
-                  <a:txBody>
-                    <a:bodyPr/>
-                    <a:lstStyle/>
-                    <a:p>
-                      <a:pPr marL="0" indent="0" algn="ctr">
-                        <a:buNone/>
-                      </a:pPr>
-                      <a:r>
-                        <a:rPr lang="en-US" sz="1500" b="1" dirty="0">
-                          <a:solidFill>
-                            <a:schemeClr val="bg1"/>
-                          </a:solidFill>
-                        </a:rPr>
-                        <a:t>Ours</a:t>
-                      </a:r>
-                      <a:endParaRPr lang="en-US" sz="1500" dirty="0"/>
-                    </a:p>
-                  </a:txBody>
-                  <a:tcPr marL="109728" marT="0" marB="0" anchor="ctr">
-                    <a:lnL w="0" cap="flat" cmpd="sng" algn="ctr">
-                      <a:noFill/>
-                    </a:lnL>
-                    <a:lnR w="0" cap="flat" cmpd="sng" algn="ctr">
-                      <a:noFill/>
-                    </a:lnR>
-                    <a:lnT w="0" cap="flat" cmpd="sng" algn="ctr">
-                      <a:noFill/>
-                    </a:lnT>
-                    <a:lnB w="0" cap="flat" cmpd="sng" algn="ctr">
-                      <a:noFill/>
-                    </a:lnB>
-                    <a:solidFill>
-                      <a:schemeClr val="accent3"/>
-                    </a:solidFill>
-                  </a:tcPr>
-                </a:tc>
-                <a:extLst>
-                  <a:ext uri="{0D108BD9-81ED-4DB2-BD59-A6C34878D82A}">
-                    <a16:rowId xmlns:a16="http://schemas.microsoft.com/office/drawing/2014/main" val="10000"/>
-                  </a:ext>
-                </a:extLst>
-              </a:tr>
-              <a:tr h="566928">
-                <a:tc>
-                  <a:txBody>
-                    <a:bodyPr/>
-                    <a:lstStyle/>
-                    <a:p>
-                      <a:pPr marL="0" indent="0">
-                        <a:buNone/>
-                      </a:pPr>
-                      <a:r>
-                        <a:rPr lang="en-US" sz="1500" b="1" dirty="0">
-                          <a:solidFill>
-                            <a:schemeClr val="tx2"/>
-                          </a:solidFill>
-                        </a:rPr>
-                        <a:t>OpenSLR 42</a:t>
-                      </a:r>
-                      <a:endParaRPr lang="en-US" sz="1500" dirty="0"/>
-                    </a:p>
-                  </a:txBody>
-                  <a:tcPr marL="109728" marT="0" marB="0" anchor="ctr">
-                    <a:lnL w="0" cap="flat" cmpd="sng" algn="ctr">
-                      <a:noFill/>
-                    </a:lnL>
-                    <a:lnR w="0" cap="flat" cmpd="sng" algn="ctr">
-                      <a:noFill/>
-                    </a:lnR>
-                    <a:lnT w="0" cap="flat" cmpd="sng" algn="ctr">
-                      <a:noFill/>
-                    </a:lnT>
-                    <a:lnB w="12700" cap="flat" cmpd="sng" algn="ctr">
-                      <a:solidFill>
-                        <a:srgbClr val="D9DEE6"/>
-                      </a:solidFill>
-                      <a:prstDash val="solid"/>
-                      <a:round/>
-                      <a:headEnd type="none" w="med" len="med"/>
-                      <a:tailEnd type="none" w="med" len="med"/>
-                    </a:lnB>
-                  </a:tcPr>
-                </a:tc>
-                <a:tc>
-                  <a:txBody>
-                    <a:bodyPr/>
-                    <a:lstStyle/>
-                    <a:p>
-                      <a:pPr marL="0" indent="0" algn="ctr">
-                        <a:buNone/>
-                      </a:pPr>
-                      <a:r>
-                        <a:rPr lang="en-US" sz="1500" dirty="0">
-                          <a:solidFill>
-                            <a:schemeClr val="accent5"/>
-                          </a:solidFill>
-                        </a:rPr>
-                        <a:t>135</a:t>
-                      </a:r>
-                      <a:endParaRPr lang="en-US" sz="1500" dirty="0"/>
-                    </a:p>
-                  </a:txBody>
-                  <a:tcPr marL="109728" marT="0" marB="0" anchor="ctr">
-                    <a:lnL w="0" cap="flat" cmpd="sng" algn="ctr">
-                      <a:noFill/>
-                    </a:lnL>
-                    <a:lnR w="0" cap="flat" cmpd="sng" algn="ctr">
-                      <a:noFill/>
-                    </a:lnR>
-                    <a:lnT w="0" cap="flat" cmpd="sng" algn="ctr">
-                      <a:noFill/>
-                    </a:lnT>
-                    <a:lnB w="12700" cap="flat" cmpd="sng" algn="ctr">
-                      <a:solidFill>
-                        <a:srgbClr val="D9DEE6"/>
-                      </a:solidFill>
-                      <a:prstDash val="solid"/>
-                      <a:round/>
-                      <a:headEnd type="none" w="med" len="med"/>
-                      <a:tailEnd type="none" w="med" len="med"/>
-                    </a:lnB>
-                  </a:tcPr>
-                </a:tc>
-                <a:tc>
-                  <a:txBody>
-                    <a:bodyPr/>
-                    <a:lstStyle/>
-                    <a:p>
-                      <a:pPr marL="0" indent="0" algn="ctr">
-                        <a:buNone/>
-                      </a:pPr>
-                      <a:r>
-                        <a:rPr lang="en-US" sz="1500" dirty="0">
-                          <a:solidFill>
-                            <a:schemeClr val="accent5"/>
-                          </a:solidFill>
-                        </a:rPr>
-                        <a:t>350.5%</a:t>
-                      </a:r>
-                      <a:endParaRPr lang="en-US" sz="1500" dirty="0"/>
-                    </a:p>
-                  </a:txBody>
-                  <a:tcPr marL="109728" marT="0" marB="0" anchor="ctr">
-                    <a:lnL w="0" cap="flat" cmpd="sng" algn="ctr">
-                      <a:noFill/>
-                    </a:lnL>
-                    <a:lnR w="0" cap="flat" cmpd="sng" algn="ctr">
-                      <a:noFill/>
-                    </a:lnR>
-                    <a:lnT w="0" cap="flat" cmpd="sng" algn="ctr">
-                      <a:noFill/>
-                    </a:lnT>
-                    <a:lnB w="12700" cap="flat" cmpd="sng" algn="ctr">
-                      <a:solidFill>
-                        <a:srgbClr val="D9DEE6"/>
-                      </a:solidFill>
-                      <a:prstDash val="solid"/>
-                      <a:round/>
-                      <a:headEnd type="none" w="med" len="med"/>
-                      <a:tailEnd type="none" w="med" len="med"/>
-                    </a:lnB>
-                  </a:tcPr>
-                </a:tc>
-                <a:tc>
-                  <a:txBody>
-                    <a:bodyPr/>
-                    <a:lstStyle/>
-                    <a:p>
-                      <a:pPr marL="0" indent="0" algn="ctr">
-                        <a:buNone/>
-                      </a:pPr>
-                      <a:r>
-                        <a:rPr lang="en-US" sz="1500" dirty="0">
-                          <a:solidFill>
-                            <a:schemeClr val="tx1"/>
-                          </a:solidFill>
-                        </a:rPr>
-                        <a:t>27.2%</a:t>
-                      </a:r>
-                      <a:endParaRPr lang="en-US" sz="1500" dirty="0"/>
-                    </a:p>
-                  </a:txBody>
-                  <a:tcPr marL="109728" marT="0" marB="0" anchor="ctr">
-                    <a:lnL w="0" cap="flat" cmpd="sng" algn="ctr">
-                      <a:noFill/>
-                    </a:lnL>
-                    <a:lnR w="0" cap="flat" cmpd="sng" algn="ctr">
-                      <a:noFill/>
-                    </a:lnR>
-                    <a:lnT w="0" cap="flat" cmpd="sng" algn="ctr">
-                      <a:noFill/>
-                    </a:lnT>
-                    <a:lnB w="12700" cap="flat" cmpd="sng" algn="ctr">
-                      <a:solidFill>
-                        <a:srgbClr val="D9DEE6"/>
-                      </a:solidFill>
-                      <a:prstDash val="solid"/>
-                      <a:round/>
-                      <a:headEnd type="none" w="med" len="med"/>
-                      <a:tailEnd type="none" w="med" len="med"/>
-                    </a:lnB>
-                  </a:tcPr>
-                </a:tc>
-                <a:tc>
-                  <a:txBody>
-                    <a:bodyPr/>
-                    <a:lstStyle/>
-                    <a:p>
-                      <a:pPr marL="0" indent="0" algn="ctr">
-                        <a:buNone/>
-                      </a:pPr>
-                      <a:r>
-                        <a:rPr lang="en-US" sz="1500" b="1" dirty="0">
-                          <a:solidFill>
-                            <a:schemeClr val="accent3"/>
-                          </a:solidFill>
-                        </a:rPr>
-                        <a:t>12.0%</a:t>
-                      </a:r>
-                      <a:endParaRPr lang="en-US" sz="1500" dirty="0"/>
-                    </a:p>
-                  </a:txBody>
-                  <a:tcPr marL="109728" marT="0" marB="0" anchor="ctr">
-                    <a:lnL w="0" cap="flat" cmpd="sng" algn="ctr">
-                      <a:noFill/>
-                    </a:lnL>
-                    <a:lnR w="0" cap="flat" cmpd="sng" algn="ctr">
-                      <a:noFill/>
-                    </a:lnR>
-                    <a:lnT w="0" cap="flat" cmpd="sng" algn="ctr">
-                      <a:noFill/>
-                    </a:lnT>
-                    <a:lnB w="12700" cap="flat" cmpd="sng" algn="ctr">
-                      <a:solidFill>
-                        <a:srgbClr val="D9DEE6"/>
-                      </a:solidFill>
-                      <a:prstDash val="solid"/>
-                      <a:round/>
-                      <a:headEnd type="none" w="med" len="med"/>
-                      <a:tailEnd type="none" w="med" len="med"/>
-                    </a:lnB>
-                    <a:solidFill>
-                      <a:srgbClr val="E8F2F1"/>
-                    </a:solidFill>
-                  </a:tcPr>
-                </a:tc>
-                <a:extLst>
-                  <a:ext uri="{0D108BD9-81ED-4DB2-BD59-A6C34878D82A}">
-                    <a16:rowId xmlns:a16="http://schemas.microsoft.com/office/drawing/2014/main" val="10001"/>
-                  </a:ext>
-                </a:extLst>
-              </a:tr>
-              <a:tr h="566928">
-                <a:tc>
-                  <a:txBody>
-                    <a:bodyPr/>
-                    <a:lstStyle/>
-                    <a:p>
-                      <a:pPr marL="0" indent="0">
-                        <a:buNone/>
-                      </a:pPr>
-                      <a:r>
-                        <a:rPr lang="en-US" sz="1500" b="1" dirty="0">
-                          <a:solidFill>
-                            <a:schemeClr val="tx2"/>
-                          </a:solidFill>
-                        </a:rPr>
-                        <a:t>khmer_mpwt_speech</a:t>
-                      </a:r>
-                      <a:endParaRPr lang="en-US" sz="1500" dirty="0"/>
-                    </a:p>
-                  </a:txBody>
-                  <a:tcPr marL="109728" marT="0" marB="0" anchor="ctr">
-                    <a:lnL w="0" cap="flat" cmpd="sng" algn="ctr">
-                      <a:noFill/>
-                    </a:lnL>
-                    <a:lnR w="0" cap="flat" cmpd="sng" algn="ctr">
-                      <a:noFill/>
-                    </a:lnR>
-                    <a:lnT w="12700" cap="flat" cmpd="sng" algn="ctr">
-                      <a:solidFill>
-                        <a:srgbClr val="D9DEE6"/>
-                      </a:solidFill>
-                      <a:prstDash val="solid"/>
-                      <a:round/>
-                      <a:headEnd type="none" w="med" len="med"/>
-                      <a:tailEnd type="none" w="med" len="med"/>
-                    </a:lnT>
-                    <a:lnB w="12700" cap="flat" cmpd="sng" algn="ctr">
-                      <a:solidFill>
-                        <a:srgbClr val="D9DEE6"/>
-                      </a:solidFill>
-                      <a:prstDash val="solid"/>
-                      <a:round/>
-                      <a:headEnd type="none" w="med" len="med"/>
-                      <a:tailEnd type="none" w="med" len="med"/>
-                    </a:lnB>
-                  </a:tcPr>
-                </a:tc>
-                <a:tc>
-                  <a:txBody>
-                    <a:bodyPr/>
-                    <a:lstStyle/>
-                    <a:p>
-                      <a:pPr marL="0" indent="0" algn="ctr">
-                        <a:buNone/>
-                      </a:pPr>
-                      <a:r>
-                        <a:rPr lang="en-US" sz="1500" dirty="0">
-                          <a:solidFill>
-                            <a:schemeClr val="accent5"/>
-                          </a:solidFill>
-                        </a:rPr>
-                        <a:t>120</a:t>
-                      </a:r>
-                      <a:endParaRPr lang="en-US" sz="1500" dirty="0"/>
-                    </a:p>
-                  </a:txBody>
-                  <a:tcPr marL="109728" marT="0" marB="0" anchor="ctr">
-                    <a:lnL w="0" cap="flat" cmpd="sng" algn="ctr">
-                      <a:noFill/>
-                    </a:lnL>
-                    <a:lnR w="0" cap="flat" cmpd="sng" algn="ctr">
-                      <a:noFill/>
-                    </a:lnR>
-                    <a:lnT w="12700" cap="flat" cmpd="sng" algn="ctr">
-                      <a:solidFill>
-                        <a:srgbClr val="D9DEE6"/>
-                      </a:solidFill>
-                      <a:prstDash val="solid"/>
-                      <a:round/>
-                      <a:headEnd type="none" w="med" len="med"/>
-                      <a:tailEnd type="none" w="med" len="med"/>
-                    </a:lnT>
-                    <a:lnB w="12700" cap="flat" cmpd="sng" algn="ctr">
-                      <a:solidFill>
-                        <a:srgbClr val="D9DEE6"/>
-                      </a:solidFill>
-                      <a:prstDash val="solid"/>
-                      <a:round/>
-                      <a:headEnd type="none" w="med" len="med"/>
-                      <a:tailEnd type="none" w="med" len="med"/>
-                    </a:lnB>
-                  </a:tcPr>
-                </a:tc>
-                <a:tc>
-                  <a:txBody>
-                    <a:bodyPr/>
-                    <a:lstStyle/>
-                    <a:p>
-                      <a:pPr marL="0" indent="0" algn="ctr">
-                        <a:buNone/>
-                      </a:pPr>
-                      <a:r>
-                        <a:rPr lang="en-US" sz="1500" dirty="0">
-                          <a:solidFill>
-                            <a:schemeClr val="accent5"/>
-                          </a:solidFill>
-                        </a:rPr>
-                        <a:t>355.1%</a:t>
-                      </a:r>
-                      <a:endParaRPr lang="en-US" sz="1500" dirty="0"/>
-                    </a:p>
-                  </a:txBody>
-                  <a:tcPr marL="109728" marT="0" marB="0" anchor="ctr">
-                    <a:lnL w="0" cap="flat" cmpd="sng" algn="ctr">
-                      <a:noFill/>
-                    </a:lnL>
-                    <a:lnR w="0" cap="flat" cmpd="sng" algn="ctr">
-                      <a:noFill/>
-                    </a:lnR>
-                    <a:lnT w="12700" cap="flat" cmpd="sng" algn="ctr">
-                      <a:solidFill>
-                        <a:srgbClr val="D9DEE6"/>
-                      </a:solidFill>
-                      <a:prstDash val="solid"/>
-                      <a:round/>
-                      <a:headEnd type="none" w="med" len="med"/>
-                      <a:tailEnd type="none" w="med" len="med"/>
-                    </a:lnT>
-                    <a:lnB w="12700" cap="flat" cmpd="sng" algn="ctr">
-                      <a:solidFill>
-                        <a:srgbClr val="D9DEE6"/>
-                      </a:solidFill>
-                      <a:prstDash val="solid"/>
-                      <a:round/>
-                      <a:headEnd type="none" w="med" len="med"/>
-                      <a:tailEnd type="none" w="med" len="med"/>
-                    </a:lnB>
-                  </a:tcPr>
-                </a:tc>
-                <a:tc>
-                  <a:txBody>
-                    <a:bodyPr/>
-                    <a:lstStyle/>
-                    <a:p>
-                      <a:pPr marL="0" indent="0" algn="ctr">
-                        <a:buNone/>
-                      </a:pPr>
-                      <a:r>
-                        <a:rPr lang="en-US" sz="1500" dirty="0">
-                          <a:solidFill>
-                            <a:schemeClr val="tx1"/>
-                          </a:solidFill>
-                        </a:rPr>
-                        <a:t>50.6%</a:t>
-                      </a:r>
-                      <a:endParaRPr lang="en-US" sz="1500" dirty="0"/>
-                    </a:p>
-                  </a:txBody>
-                  <a:tcPr marL="109728" marT="0" marB="0" anchor="ctr">
-                    <a:lnL w="0" cap="flat" cmpd="sng" algn="ctr">
-                      <a:noFill/>
-                    </a:lnL>
-                    <a:lnR w="0" cap="flat" cmpd="sng" algn="ctr">
-                      <a:noFill/>
-                    </a:lnR>
-                    <a:lnT w="12700" cap="flat" cmpd="sng" algn="ctr">
-                      <a:solidFill>
-                        <a:srgbClr val="D9DEE6"/>
-                      </a:solidFill>
-                      <a:prstDash val="solid"/>
-                      <a:round/>
-                      <a:headEnd type="none" w="med" len="med"/>
-                      <a:tailEnd type="none" w="med" len="med"/>
-                    </a:lnT>
-                    <a:lnB w="12700" cap="flat" cmpd="sng" algn="ctr">
-                      <a:solidFill>
-                        <a:srgbClr val="D9DEE6"/>
-                      </a:solidFill>
-                      <a:prstDash val="solid"/>
-                      <a:round/>
-                      <a:headEnd type="none" w="med" len="med"/>
-                      <a:tailEnd type="none" w="med" len="med"/>
-                    </a:lnB>
-                  </a:tcPr>
-                </a:tc>
-                <a:tc>
-                  <a:txBody>
-                    <a:bodyPr/>
-                    <a:lstStyle/>
-                    <a:p>
-                      <a:pPr marL="0" indent="0" algn="ctr">
-                        <a:buNone/>
-                      </a:pPr>
-                      <a:r>
-                        <a:rPr lang="en-US" sz="1500" b="1" dirty="0">
-                          <a:solidFill>
-                            <a:schemeClr val="accent3"/>
-                          </a:solidFill>
-                        </a:rPr>
-                        <a:t>14.5%</a:t>
-                      </a:r>
-                      <a:endParaRPr lang="en-US" sz="1500" dirty="0"/>
-                    </a:p>
-                  </a:txBody>
-                  <a:tcPr marL="109728" marT="0" marB="0" anchor="ctr">
-                    <a:lnL w="0" cap="flat" cmpd="sng" algn="ctr">
-                      <a:noFill/>
-                    </a:lnL>
-                    <a:lnR w="0" cap="flat" cmpd="sng" algn="ctr">
-                      <a:noFill/>
-                    </a:lnR>
-                    <a:lnT w="12700" cap="flat" cmpd="sng" algn="ctr">
-                      <a:solidFill>
-                        <a:srgbClr val="D9DEE6"/>
-                      </a:solidFill>
-                      <a:prstDash val="solid"/>
-                      <a:round/>
-                      <a:headEnd type="none" w="med" len="med"/>
-                      <a:tailEnd type="none" w="med" len="med"/>
-                    </a:lnT>
-                    <a:lnB w="12700" cap="flat" cmpd="sng" algn="ctr">
-                      <a:solidFill>
-                        <a:srgbClr val="D9DEE6"/>
-                      </a:solidFill>
-                      <a:prstDash val="solid"/>
-                      <a:round/>
-                      <a:headEnd type="none" w="med" len="med"/>
-                      <a:tailEnd type="none" w="med" len="med"/>
-                    </a:lnB>
-                    <a:solidFill>
-                      <a:srgbClr val="E8F2F1"/>
-                    </a:solidFill>
-                  </a:tcPr>
-                </a:tc>
-                <a:extLst>
-                  <a:ext uri="{0D108BD9-81ED-4DB2-BD59-A6C34878D82A}">
-                    <a16:rowId xmlns:a16="http://schemas.microsoft.com/office/drawing/2014/main" val="10002"/>
-                  </a:ext>
-                </a:extLst>
-              </a:tr>
-              <a:tr h="566928">
-                <a:tc>
-                  <a:txBody>
-                    <a:bodyPr/>
-                    <a:lstStyle/>
-                    <a:p>
-                      <a:pPr marL="0" indent="0">
-                        <a:buNone/>
-                      </a:pPr>
-                      <a:r>
-                        <a:rPr lang="en-US" sz="1500" b="1" dirty="0">
-                          <a:solidFill>
-                            <a:schemeClr val="tx2"/>
-                          </a:solidFill>
-                        </a:rPr>
-                        <a:t>khmer_kheng_info_speech</a:t>
-                      </a:r>
-                      <a:endParaRPr lang="en-US" sz="1500" dirty="0"/>
-                    </a:p>
-                  </a:txBody>
-                  <a:tcPr marL="109728" marT="0" marB="0" anchor="ctr">
-                    <a:lnL w="0" cap="flat" cmpd="sng" algn="ctr">
-                      <a:noFill/>
-                    </a:lnL>
-                    <a:lnR w="0" cap="flat" cmpd="sng" algn="ctr">
-                      <a:noFill/>
-                    </a:lnR>
-                    <a:lnT w="12700" cap="flat" cmpd="sng" algn="ctr">
-                      <a:solidFill>
-                        <a:srgbClr val="D9DEE6"/>
-                      </a:solidFill>
-                      <a:prstDash val="solid"/>
-                      <a:round/>
-                      <a:headEnd type="none" w="med" len="med"/>
-                      <a:tailEnd type="none" w="med" len="med"/>
-                    </a:lnT>
-                    <a:lnB w="12700" cap="flat" cmpd="sng" algn="ctr">
-                      <a:solidFill>
-                        <a:srgbClr val="D9DEE6"/>
-                      </a:solidFill>
-                      <a:prstDash val="solid"/>
-                      <a:round/>
-                      <a:headEnd type="none" w="med" len="med"/>
-                      <a:tailEnd type="none" w="med" len="med"/>
-                    </a:lnB>
-                  </a:tcPr>
-                </a:tc>
-                <a:tc>
-                  <a:txBody>
-                    <a:bodyPr/>
-                    <a:lstStyle/>
-                    <a:p>
-                      <a:pPr marL="0" indent="0" algn="ctr">
-                        <a:buNone/>
-                      </a:pPr>
-                      <a:r>
-                        <a:rPr lang="en-US" sz="1500" dirty="0">
-                          <a:solidFill>
-                            <a:schemeClr val="accent5"/>
-                          </a:solidFill>
-                        </a:rPr>
-                        <a:t>132</a:t>
-                      </a:r>
-                      <a:endParaRPr lang="en-US" sz="1500" dirty="0"/>
-                    </a:p>
-                  </a:txBody>
-                  <a:tcPr marL="109728" marT="0" marB="0" anchor="ctr">
-                    <a:lnL w="0" cap="flat" cmpd="sng" algn="ctr">
-                      <a:noFill/>
-                    </a:lnL>
-                    <a:lnR w="0" cap="flat" cmpd="sng" algn="ctr">
-                      <a:noFill/>
-                    </a:lnR>
-                    <a:lnT w="12700" cap="flat" cmpd="sng" algn="ctr">
-                      <a:solidFill>
-                        <a:srgbClr val="D9DEE6"/>
-                      </a:solidFill>
-                      <a:prstDash val="solid"/>
-                      <a:round/>
-                      <a:headEnd type="none" w="med" len="med"/>
-                      <a:tailEnd type="none" w="med" len="med"/>
-                    </a:lnT>
-                    <a:lnB w="12700" cap="flat" cmpd="sng" algn="ctr">
-                      <a:solidFill>
-                        <a:srgbClr val="D9DEE6"/>
-                      </a:solidFill>
-                      <a:prstDash val="solid"/>
-                      <a:round/>
-                      <a:headEnd type="none" w="med" len="med"/>
-                      <a:tailEnd type="none" w="med" len="med"/>
-                    </a:lnB>
-                  </a:tcPr>
-                </a:tc>
-                <a:tc>
-                  <a:txBody>
-                    <a:bodyPr/>
-                    <a:lstStyle/>
-                    <a:p>
-                      <a:pPr marL="0" indent="0" algn="ctr">
-                        <a:buNone/>
-                      </a:pPr>
-                      <a:r>
-                        <a:rPr lang="en-US" sz="1500" dirty="0">
-                          <a:solidFill>
-                            <a:schemeClr val="accent5"/>
-                          </a:solidFill>
-                        </a:rPr>
-                        <a:t>1,478.3%</a:t>
-                      </a:r>
-                      <a:endParaRPr lang="en-US" sz="1500" dirty="0"/>
-                    </a:p>
-                  </a:txBody>
-                  <a:tcPr marL="109728" marT="0" marB="0" anchor="ctr">
-                    <a:lnL w="0" cap="flat" cmpd="sng" algn="ctr">
-                      <a:noFill/>
-                    </a:lnL>
-                    <a:lnR w="0" cap="flat" cmpd="sng" algn="ctr">
-                      <a:noFill/>
-                    </a:lnR>
-                    <a:lnT w="12700" cap="flat" cmpd="sng" algn="ctr">
-                      <a:solidFill>
-                        <a:srgbClr val="D9DEE6"/>
-                      </a:solidFill>
-                      <a:prstDash val="solid"/>
-                      <a:round/>
-                      <a:headEnd type="none" w="med" len="med"/>
-                      <a:tailEnd type="none" w="med" len="med"/>
-                    </a:lnT>
-                    <a:lnB w="12700" cap="flat" cmpd="sng" algn="ctr">
-                      <a:solidFill>
-                        <a:srgbClr val="D9DEE6"/>
-                      </a:solidFill>
-                      <a:prstDash val="solid"/>
-                      <a:round/>
-                      <a:headEnd type="none" w="med" len="med"/>
-                      <a:tailEnd type="none" w="med" len="med"/>
-                    </a:lnB>
-                  </a:tcPr>
-                </a:tc>
-                <a:tc>
-                  <a:txBody>
-                    <a:bodyPr/>
-                    <a:lstStyle/>
-                    <a:p>
-                      <a:pPr marL="0" indent="0" algn="ctr">
-                        <a:buNone/>
-                      </a:pPr>
-                      <a:r>
-                        <a:rPr lang="en-US" sz="1500" dirty="0">
-                          <a:solidFill>
-                            <a:schemeClr val="tx1"/>
-                          </a:solidFill>
-                        </a:rPr>
-                        <a:t>40.1%</a:t>
-                      </a:r>
-                      <a:endParaRPr lang="en-US" sz="1500" dirty="0"/>
-                    </a:p>
-                  </a:txBody>
-                  <a:tcPr marL="109728" marT="0" marB="0" anchor="ctr">
-                    <a:lnL w="0" cap="flat" cmpd="sng" algn="ctr">
-                      <a:noFill/>
-                    </a:lnL>
-                    <a:lnR w="0" cap="flat" cmpd="sng" algn="ctr">
-                      <a:noFill/>
-                    </a:lnR>
-                    <a:lnT w="12700" cap="flat" cmpd="sng" algn="ctr">
-                      <a:solidFill>
-                        <a:srgbClr val="D9DEE6"/>
-                      </a:solidFill>
-                      <a:prstDash val="solid"/>
-                      <a:round/>
-                      <a:headEnd type="none" w="med" len="med"/>
-                      <a:tailEnd type="none" w="med" len="med"/>
-                    </a:lnT>
-                    <a:lnB w="12700" cap="flat" cmpd="sng" algn="ctr">
-                      <a:solidFill>
-                        <a:srgbClr val="D9DEE6"/>
-                      </a:solidFill>
-                      <a:prstDash val="solid"/>
-                      <a:round/>
-                      <a:headEnd type="none" w="med" len="med"/>
-                      <a:tailEnd type="none" w="med" len="med"/>
-                    </a:lnB>
-                  </a:tcPr>
-                </a:tc>
-                <a:tc>
-                  <a:txBody>
-                    <a:bodyPr/>
-                    <a:lstStyle/>
-                    <a:p>
-                      <a:pPr marL="0" indent="0" algn="ctr">
-                        <a:buNone/>
-                      </a:pPr>
-                      <a:r>
-                        <a:rPr lang="en-US" sz="1500" b="1" dirty="0">
-                          <a:solidFill>
-                            <a:schemeClr val="accent3"/>
-                          </a:solidFill>
-                        </a:rPr>
-                        <a:t>15.3%</a:t>
-                      </a:r>
-                      <a:endParaRPr lang="en-US" sz="1500" dirty="0"/>
-                    </a:p>
-                  </a:txBody>
-                  <a:tcPr marL="109728" marT="0" marB="0" anchor="ctr">
-                    <a:lnL w="0" cap="flat" cmpd="sng" algn="ctr">
-                      <a:noFill/>
-                    </a:lnL>
-                    <a:lnR w="0" cap="flat" cmpd="sng" algn="ctr">
-                      <a:noFill/>
-                    </a:lnR>
-                    <a:lnT w="12700" cap="flat" cmpd="sng" algn="ctr">
-                      <a:solidFill>
-                        <a:srgbClr val="D9DEE6"/>
-                      </a:solidFill>
-                      <a:prstDash val="solid"/>
-                      <a:round/>
-                      <a:headEnd type="none" w="med" len="med"/>
-                      <a:tailEnd type="none" w="med" len="med"/>
-                    </a:lnT>
-                    <a:lnB w="12700" cap="flat" cmpd="sng" algn="ctr">
-                      <a:solidFill>
-                        <a:srgbClr val="D9DEE6"/>
-                      </a:solidFill>
-                      <a:prstDash val="solid"/>
-                      <a:round/>
-                      <a:headEnd type="none" w="med" len="med"/>
-                      <a:tailEnd type="none" w="med" len="med"/>
-                    </a:lnB>
-                    <a:solidFill>
-                      <a:srgbClr val="E8F2F1"/>
-                    </a:solidFill>
-                  </a:tcPr>
-                </a:tc>
-                <a:extLst>
-                  <a:ext uri="{0D108BD9-81ED-4DB2-BD59-A6C34878D82A}">
-                    <a16:rowId xmlns:a16="http://schemas.microsoft.com/office/drawing/2014/main" val="10003"/>
-                  </a:ext>
-                </a:extLst>
-              </a:tr>
-              <a:tr h="566928">
-                <a:tc>
-                  <a:txBody>
-                    <a:bodyPr/>
-                    <a:lstStyle/>
-                    <a:p>
-                      <a:pPr marL="0" indent="0">
-                        <a:buNone/>
-                      </a:pPr>
-                      <a:r>
-                        <a:rPr lang="en-US" sz="1500" b="1" dirty="0">
-                          <a:solidFill>
-                            <a:schemeClr val="tx2"/>
-                          </a:solidFill>
-                        </a:rPr>
-                        <a:t>RFI Khmer</a:t>
-                      </a:r>
-                      <a:endParaRPr lang="en-US" sz="1500" dirty="0"/>
-                    </a:p>
-                  </a:txBody>
-                  <a:tcPr marL="109728" marT="0" marB="0" anchor="ctr">
-                    <a:lnL w="0" cap="flat" cmpd="sng" algn="ctr">
-                      <a:noFill/>
-                    </a:lnL>
-                    <a:lnR w="0" cap="flat" cmpd="sng" algn="ctr">
-                      <a:noFill/>
-                    </a:lnR>
-                    <a:lnT w="12700" cap="flat" cmpd="sng" algn="ctr">
-                      <a:solidFill>
-                        <a:srgbClr val="D9DEE6"/>
-                      </a:solidFill>
-                      <a:prstDash val="solid"/>
-                      <a:round/>
-                      <a:headEnd type="none" w="med" len="med"/>
-                      <a:tailEnd type="none" w="med" len="med"/>
-                    </a:lnT>
-                    <a:lnB w="12700" cap="flat" cmpd="sng" algn="ctr">
-                      <a:solidFill>
-                        <a:srgbClr val="D9DEE6"/>
-                      </a:solidFill>
-                      <a:prstDash val="solid"/>
-                      <a:round/>
-                      <a:headEnd type="none" w="med" len="med"/>
-                      <a:tailEnd type="none" w="med" len="med"/>
-                    </a:lnB>
-                  </a:tcPr>
-                </a:tc>
-                <a:tc>
-                  <a:txBody>
-                    <a:bodyPr/>
-                    <a:lstStyle/>
-                    <a:p>
-                      <a:pPr marL="0" indent="0" algn="ctr">
-                        <a:buNone/>
-                      </a:pPr>
-                      <a:r>
-                        <a:rPr lang="en-US" sz="1500" dirty="0">
-                          <a:solidFill>
-                            <a:schemeClr val="accent5"/>
-                          </a:solidFill>
-                        </a:rPr>
-                        <a:t>4</a:t>
-                      </a:r>
-                      <a:endParaRPr lang="en-US" sz="1500" dirty="0"/>
-                    </a:p>
-                  </a:txBody>
-                  <a:tcPr marL="109728" marT="0" marB="0" anchor="ctr">
-                    <a:lnL w="0" cap="flat" cmpd="sng" algn="ctr">
-                      <a:noFill/>
-                    </a:lnL>
-                    <a:lnR w="0" cap="flat" cmpd="sng" algn="ctr">
-                      <a:noFill/>
-                    </a:lnR>
-                    <a:lnT w="12700" cap="flat" cmpd="sng" algn="ctr">
-                      <a:solidFill>
-                        <a:srgbClr val="D9DEE6"/>
-                      </a:solidFill>
-                      <a:prstDash val="solid"/>
-                      <a:round/>
-                      <a:headEnd type="none" w="med" len="med"/>
-                      <a:tailEnd type="none" w="med" len="med"/>
-                    </a:lnT>
-                    <a:lnB w="12700" cap="flat" cmpd="sng" algn="ctr">
-                      <a:solidFill>
-                        <a:srgbClr val="D9DEE6"/>
-                      </a:solidFill>
-                      <a:prstDash val="solid"/>
-                      <a:round/>
-                      <a:headEnd type="none" w="med" len="med"/>
-                      <a:tailEnd type="none" w="med" len="med"/>
-                    </a:lnB>
-                  </a:tcPr>
-                </a:tc>
-                <a:tc>
-                  <a:txBody>
-                    <a:bodyPr/>
-                    <a:lstStyle/>
-                    <a:p>
-                      <a:pPr marL="0" indent="0" algn="ctr">
-                        <a:buNone/>
-                      </a:pPr>
-                      <a:r>
-                        <a:rPr lang="en-US" sz="1500" dirty="0">
-                          <a:solidFill>
-                            <a:schemeClr val="accent5"/>
-                          </a:solidFill>
-                        </a:rPr>
-                        <a:t>229.6%</a:t>
-                      </a:r>
-                      <a:endParaRPr lang="en-US" sz="1500" dirty="0"/>
-                    </a:p>
-                  </a:txBody>
-                  <a:tcPr marL="109728" marT="0" marB="0" anchor="ctr">
-                    <a:lnL w="0" cap="flat" cmpd="sng" algn="ctr">
-                      <a:noFill/>
-                    </a:lnL>
-                    <a:lnR w="0" cap="flat" cmpd="sng" algn="ctr">
-                      <a:noFill/>
-                    </a:lnR>
-                    <a:lnT w="12700" cap="flat" cmpd="sng" algn="ctr">
-                      <a:solidFill>
-                        <a:srgbClr val="D9DEE6"/>
-                      </a:solidFill>
-                      <a:prstDash val="solid"/>
-                      <a:round/>
-                      <a:headEnd type="none" w="med" len="med"/>
-                      <a:tailEnd type="none" w="med" len="med"/>
-                    </a:lnT>
-                    <a:lnB w="12700" cap="flat" cmpd="sng" algn="ctr">
-                      <a:solidFill>
-                        <a:srgbClr val="D9DEE6"/>
-                      </a:solidFill>
-                      <a:prstDash val="solid"/>
-                      <a:round/>
-                      <a:headEnd type="none" w="med" len="med"/>
-                      <a:tailEnd type="none" w="med" len="med"/>
-                    </a:lnB>
-                  </a:tcPr>
-                </a:tc>
-                <a:tc>
-                  <a:txBody>
-                    <a:bodyPr/>
-                    <a:lstStyle/>
-                    <a:p>
-                      <a:pPr marL="0" indent="0" algn="ctr">
-                        <a:buNone/>
-                      </a:pPr>
-                      <a:r>
-                        <a:rPr lang="en-US" sz="1500" dirty="0">
-                          <a:solidFill>
-                            <a:schemeClr val="tx1"/>
-                          </a:solidFill>
-                        </a:rPr>
-                        <a:t>49.8%</a:t>
-                      </a:r>
-                      <a:endParaRPr lang="en-US" sz="1500" dirty="0"/>
-                    </a:p>
-                  </a:txBody>
-                  <a:tcPr marL="109728" marT="0" marB="0" anchor="ctr">
-                    <a:lnL w="0" cap="flat" cmpd="sng" algn="ctr">
-                      <a:noFill/>
-                    </a:lnL>
-                    <a:lnR w="0" cap="flat" cmpd="sng" algn="ctr">
-                      <a:noFill/>
-                    </a:lnR>
-                    <a:lnT w="12700" cap="flat" cmpd="sng" algn="ctr">
-                      <a:solidFill>
-                        <a:srgbClr val="D9DEE6"/>
-                      </a:solidFill>
-                      <a:prstDash val="solid"/>
-                      <a:round/>
-                      <a:headEnd type="none" w="med" len="med"/>
-                      <a:tailEnd type="none" w="med" len="med"/>
-                    </a:lnT>
-                    <a:lnB w="12700" cap="flat" cmpd="sng" algn="ctr">
-                      <a:solidFill>
-                        <a:srgbClr val="D9DEE6"/>
-                      </a:solidFill>
-                      <a:prstDash val="solid"/>
-                      <a:round/>
-                      <a:headEnd type="none" w="med" len="med"/>
-                      <a:tailEnd type="none" w="med" len="med"/>
-                    </a:lnB>
-                  </a:tcPr>
-                </a:tc>
-                <a:tc>
-                  <a:txBody>
-                    <a:bodyPr/>
-                    <a:lstStyle/>
-                    <a:p>
-                      <a:pPr marL="0" indent="0" algn="ctr">
-                        <a:buNone/>
-                      </a:pPr>
-                      <a:r>
-                        <a:rPr lang="en-US" sz="1500" b="1" dirty="0">
-                          <a:solidFill>
-                            <a:schemeClr val="accent3"/>
-                          </a:solidFill>
-                        </a:rPr>
-                        <a:t>18.7%</a:t>
-                      </a:r>
-                      <a:endParaRPr lang="en-US" sz="1500" dirty="0"/>
-                    </a:p>
-                  </a:txBody>
-                  <a:tcPr marL="109728" marT="0" marB="0" anchor="ctr">
-                    <a:lnL w="0" cap="flat" cmpd="sng" algn="ctr">
-                      <a:noFill/>
-                    </a:lnL>
-                    <a:lnR w="0" cap="flat" cmpd="sng" algn="ctr">
-                      <a:noFill/>
-                    </a:lnR>
-                    <a:lnT w="12700" cap="flat" cmpd="sng" algn="ctr">
-                      <a:solidFill>
-                        <a:srgbClr val="D9DEE6"/>
-                      </a:solidFill>
-                      <a:prstDash val="solid"/>
-                      <a:round/>
-                      <a:headEnd type="none" w="med" len="med"/>
-                      <a:tailEnd type="none" w="med" len="med"/>
-                    </a:lnT>
-                    <a:lnB w="12700" cap="flat" cmpd="sng" algn="ctr">
-                      <a:solidFill>
-                        <a:srgbClr val="D9DEE6"/>
-                      </a:solidFill>
-                      <a:prstDash val="solid"/>
-                      <a:round/>
-                      <a:headEnd type="none" w="med" len="med"/>
-                      <a:tailEnd type="none" w="med" len="med"/>
-                    </a:lnB>
-                    <a:solidFill>
-                      <a:srgbClr val="E8F2F1"/>
-                    </a:solidFill>
-                  </a:tcPr>
-                </a:tc>
-                <a:extLst>
-                  <a:ext uri="{0D108BD9-81ED-4DB2-BD59-A6C34878D82A}">
-                    <a16:rowId xmlns:a16="http://schemas.microsoft.com/office/drawing/2014/main" val="10004"/>
-                  </a:ext>
-                </a:extLst>
-              </a:tr>
-              <a:tr h="566928">
-                <a:tc>
-                  <a:txBody>
-                    <a:bodyPr/>
-                    <a:lstStyle/>
-                    <a:p>
-                      <a:pPr marL="0" indent="0">
-                        <a:buNone/>
-                      </a:pPr>
-                      <a:r>
-                        <a:rPr lang="en-US" sz="1500" b="1" dirty="0">
-                          <a:solidFill>
-                            <a:schemeClr val="tx2"/>
-                          </a:solidFill>
-                        </a:rPr>
-                        <a:t>km-speech-corpus</a:t>
-                      </a:r>
-                      <a:endParaRPr lang="en-US" sz="1500" dirty="0"/>
-                    </a:p>
-                  </a:txBody>
-                  <a:tcPr marL="109728" marT="0" marB="0" anchor="ctr">
-                    <a:lnL w="0" cap="flat" cmpd="sng" algn="ctr">
-                      <a:noFill/>
-                    </a:lnL>
-                    <a:lnR w="0" cap="flat" cmpd="sng" algn="ctr">
-                      <a:noFill/>
-                    </a:lnR>
-                    <a:lnT w="12700" cap="flat" cmpd="sng" algn="ctr">
-                      <a:solidFill>
-                        <a:srgbClr val="D9DEE6"/>
-                      </a:solidFill>
-                      <a:prstDash val="solid"/>
-                      <a:round/>
-                      <a:headEnd type="none" w="med" len="med"/>
-                      <a:tailEnd type="none" w="med" len="med"/>
-                    </a:lnT>
-                    <a:lnB w="12700" cap="flat" cmpd="sng" algn="ctr">
-                      <a:solidFill>
-                        <a:srgbClr val="D9DEE6"/>
-                      </a:solidFill>
-                      <a:prstDash val="solid"/>
-                      <a:round/>
-                      <a:headEnd type="none" w="med" len="med"/>
-                      <a:tailEnd type="none" w="med" len="med"/>
-                    </a:lnB>
-                  </a:tcPr>
-                </a:tc>
-                <a:tc>
-                  <a:txBody>
-                    <a:bodyPr/>
-                    <a:lstStyle/>
-                    <a:p>
-                      <a:pPr marL="0" indent="0" algn="ctr">
-                        <a:buNone/>
-                      </a:pPr>
-                      <a:r>
-                        <a:rPr lang="en-US" sz="1500" dirty="0">
-                          <a:solidFill>
-                            <a:schemeClr val="accent5"/>
-                          </a:solidFill>
-                        </a:rPr>
-                        <a:t>788</a:t>
-                      </a:r>
-                      <a:endParaRPr lang="en-US" sz="1500" dirty="0"/>
-                    </a:p>
-                  </a:txBody>
-                  <a:tcPr marL="109728" marT="0" marB="0" anchor="ctr">
-                    <a:lnL w="0" cap="flat" cmpd="sng" algn="ctr">
-                      <a:noFill/>
-                    </a:lnL>
-                    <a:lnR w="0" cap="flat" cmpd="sng" algn="ctr">
-                      <a:noFill/>
-                    </a:lnR>
-                    <a:lnT w="12700" cap="flat" cmpd="sng" algn="ctr">
-                      <a:solidFill>
-                        <a:srgbClr val="D9DEE6"/>
-                      </a:solidFill>
-                      <a:prstDash val="solid"/>
-                      <a:round/>
-                      <a:headEnd type="none" w="med" len="med"/>
-                      <a:tailEnd type="none" w="med" len="med"/>
-                    </a:lnT>
-                    <a:lnB w="12700" cap="flat" cmpd="sng" algn="ctr">
-                      <a:solidFill>
-                        <a:srgbClr val="D9DEE6"/>
-                      </a:solidFill>
-                      <a:prstDash val="solid"/>
-                      <a:round/>
-                      <a:headEnd type="none" w="med" len="med"/>
-                      <a:tailEnd type="none" w="med" len="med"/>
-                    </a:lnB>
-                  </a:tcPr>
-                </a:tc>
-                <a:tc>
-                  <a:txBody>
-                    <a:bodyPr/>
-                    <a:lstStyle/>
-                    <a:p>
-                      <a:pPr marL="0" indent="0" algn="ctr">
-                        <a:buNone/>
-                      </a:pPr>
-                      <a:r>
-                        <a:rPr lang="en-US" sz="1500" dirty="0">
-                          <a:solidFill>
-                            <a:schemeClr val="accent5"/>
-                          </a:solidFill>
-                        </a:rPr>
-                        <a:t>365.0%</a:t>
-                      </a:r>
-                      <a:endParaRPr lang="en-US" sz="1500" dirty="0"/>
-                    </a:p>
-                  </a:txBody>
-                  <a:tcPr marL="109728" marT="0" marB="0" anchor="ctr">
-                    <a:lnL w="0" cap="flat" cmpd="sng" algn="ctr">
-                      <a:noFill/>
-                    </a:lnL>
-                    <a:lnR w="0" cap="flat" cmpd="sng" algn="ctr">
-                      <a:noFill/>
-                    </a:lnR>
-                    <a:lnT w="12700" cap="flat" cmpd="sng" algn="ctr">
-                      <a:solidFill>
-                        <a:srgbClr val="D9DEE6"/>
-                      </a:solidFill>
-                      <a:prstDash val="solid"/>
-                      <a:round/>
-                      <a:headEnd type="none" w="med" len="med"/>
-                      <a:tailEnd type="none" w="med" len="med"/>
-                    </a:lnT>
-                    <a:lnB w="12700" cap="flat" cmpd="sng" algn="ctr">
-                      <a:solidFill>
-                        <a:srgbClr val="D9DEE6"/>
-                      </a:solidFill>
-                      <a:prstDash val="solid"/>
-                      <a:round/>
-                      <a:headEnd type="none" w="med" len="med"/>
-                      <a:tailEnd type="none" w="med" len="med"/>
-                    </a:lnB>
-                  </a:tcPr>
-                </a:tc>
-                <a:tc>
-                  <a:txBody>
-                    <a:bodyPr/>
-                    <a:lstStyle/>
-                    <a:p>
-                      <a:pPr marL="0" indent="0" algn="ctr">
-                        <a:buNone/>
-                      </a:pPr>
-                      <a:r>
-                        <a:rPr lang="en-US" sz="1500" dirty="0">
-                          <a:solidFill>
-                            <a:schemeClr val="tx1"/>
-                          </a:solidFill>
-                        </a:rPr>
-                        <a:t>68.3%</a:t>
-                      </a:r>
-                      <a:endParaRPr lang="en-US" sz="1500" dirty="0"/>
-                    </a:p>
-                  </a:txBody>
-                  <a:tcPr marL="109728" marT="0" marB="0" anchor="ctr">
-                    <a:lnL w="0" cap="flat" cmpd="sng" algn="ctr">
-                      <a:noFill/>
-                    </a:lnL>
-                    <a:lnR w="0" cap="flat" cmpd="sng" algn="ctr">
-                      <a:noFill/>
-                    </a:lnR>
-                    <a:lnT w="12700" cap="flat" cmpd="sng" algn="ctr">
-                      <a:solidFill>
-                        <a:srgbClr val="D9DEE6"/>
-                      </a:solidFill>
-                      <a:prstDash val="solid"/>
-                      <a:round/>
-                      <a:headEnd type="none" w="med" len="med"/>
-                      <a:tailEnd type="none" w="med" len="med"/>
-                    </a:lnT>
-                    <a:lnB w="12700" cap="flat" cmpd="sng" algn="ctr">
-                      <a:solidFill>
-                        <a:srgbClr val="D9DEE6"/>
-                      </a:solidFill>
-                      <a:prstDash val="solid"/>
-                      <a:round/>
-                      <a:headEnd type="none" w="med" len="med"/>
-                      <a:tailEnd type="none" w="med" len="med"/>
-                    </a:lnB>
-                  </a:tcPr>
-                </a:tc>
-                <a:tc>
-                  <a:txBody>
-                    <a:bodyPr/>
-                    <a:lstStyle/>
-                    <a:p>
-                      <a:pPr marL="0" indent="0" algn="ctr">
-                        <a:buNone/>
-                      </a:pPr>
-                      <a:r>
-                        <a:rPr lang="en-US" sz="1500" b="1" dirty="0">
-                          <a:solidFill>
-                            <a:schemeClr val="accent3"/>
-                          </a:solidFill>
-                        </a:rPr>
-                        <a:t>30.0%</a:t>
-                      </a:r>
-                      <a:endParaRPr lang="en-US" sz="1500" dirty="0"/>
-                    </a:p>
-                  </a:txBody>
-                  <a:tcPr marL="109728" marT="0" marB="0" anchor="ctr">
-                    <a:lnL w="0" cap="flat" cmpd="sng" algn="ctr">
-                      <a:noFill/>
-                    </a:lnL>
-                    <a:lnR w="0" cap="flat" cmpd="sng" algn="ctr">
-                      <a:noFill/>
-                    </a:lnR>
-                    <a:lnT w="12700" cap="flat" cmpd="sng" algn="ctr">
-                      <a:solidFill>
-                        <a:srgbClr val="D9DEE6"/>
-                      </a:solidFill>
-                      <a:prstDash val="solid"/>
-                      <a:round/>
-                      <a:headEnd type="none" w="med" len="med"/>
-                      <a:tailEnd type="none" w="med" len="med"/>
-                    </a:lnT>
-                    <a:lnB w="12700" cap="flat" cmpd="sng" algn="ctr">
-                      <a:solidFill>
-                        <a:srgbClr val="D9DEE6"/>
-                      </a:solidFill>
-                      <a:prstDash val="solid"/>
-                      <a:round/>
-                      <a:headEnd type="none" w="med" len="med"/>
-                      <a:tailEnd type="none" w="med" len="med"/>
-                    </a:lnB>
-                    <a:solidFill>
-                      <a:srgbClr val="E8F2F1"/>
-                    </a:solidFill>
-                  </a:tcPr>
-                </a:tc>
-                <a:extLst>
-                  <a:ext uri="{0D108BD9-81ED-4DB2-BD59-A6C34878D82A}">
-                    <a16:rowId xmlns:a16="http://schemas.microsoft.com/office/drawing/2014/main" val="10005"/>
-                  </a:ext>
-                </a:extLst>
-              </a:tr>
-            </a:tbl>
-          </a:graphicData>
-        </a:graphic>
-      </p:graphicFrame>
-      <p:sp>
-        <p:nvSpPr>
-          <p:cNvPr id="5" name="Text 2"/>
-          <p:cNvSpPr txBox="1"/>
-          <p:nvPr/>
-        </p:nvSpPr>
-        <p:spPr>
-          <a:xfrm>
-            <a:off x="548640" y="5349240"/>
-            <a:ext cx="7040880" cy="274320"/>
-          </a:xfrm>
-          <a:prstGeom prst="rect">
-            <a:avLst/>
-          </a:prstGeom>
-          <a:noFill/>
-          <a:ln/>
-        </p:spPr>
-        <p:txBody>
-          <a:bodyPr wrap="square" lIns="0" tIns="0" rIns="0" bIns="0" rtlCol="0" anchor="t"/>
-          <a:lstStyle/>
-          <a:p>
-            <a:pPr marL="0" indent="0">
-              <a:buNone/>
-            </a:pPr>
-            <a:r>
-              <a:rPr lang="en-US" sz="1200" i="1" dirty="0">
-                <a:solidFill>
-                  <a:schemeClr val="accent5"/>
-                </a:solidFill>
-              </a:rPr>
-              <a:t>CER without spaces, lower is better. RFI has only 4 test clips.</a:t>
-            </a:r>
-            <a:endParaRPr lang="en-US" sz="1200" dirty="0"/>
-          </a:p>
-        </p:txBody>
-      </p:sp>
-      <p:sp>
-        <p:nvSpPr>
-          <p:cNvPr id="6" name="insight 1"/>
-          <p:cNvSpPr/>
-          <p:nvPr/>
-        </p:nvSpPr>
-        <p:spPr>
-          <a:xfrm>
-            <a:off x="7955280" y="1783080"/>
-            <a:ext cx="3685032" cy="1737360"/>
-          </a:xfrm>
-          <a:prstGeom prst="roundRect">
-            <a:avLst>
-              <a:gd name="adj" fmla="val 4211"/>
-            </a:avLst>
-          </a:prstGeom>
-          <a:solidFill>
-            <a:schemeClr val="bg2"/>
-          </a:solidFill>
-          <a:ln w="12700">
-            <a:solidFill>
-              <a:schemeClr val="bg2"/>
-            </a:solidFill>
-            <a:prstDash val="solid"/>
-          </a:ln>
-        </p:spPr>
-        <p:txBody>
-          <a:bodyPr/>
-          <a:lstStyle/>
-          <a:p>
-            <a:endParaRPr lang="en-US"/>
-          </a:p>
-        </p:txBody>
-      </p:sp>
-      <p:sp>
-        <p:nvSpPr>
-          <p:cNvPr id="7" name="Text 4"/>
-          <p:cNvSpPr txBox="1"/>
-          <p:nvPr/>
-        </p:nvSpPr>
-        <p:spPr>
-          <a:xfrm>
-            <a:off x="8183880" y="1920240"/>
-            <a:ext cx="3291840" cy="320040"/>
-          </a:xfrm>
-          <a:prstGeom prst="rect">
-            <a:avLst/>
-          </a:prstGeom>
-          <a:noFill/>
-          <a:ln/>
-        </p:spPr>
-        <p:txBody>
-          <a:bodyPr wrap="square" lIns="0" tIns="0" rIns="0" bIns="0" rtlCol="0" anchor="t"/>
-          <a:lstStyle/>
-          <a:p>
-            <a:pPr marL="0" indent="0">
-              <a:buNone/>
-            </a:pPr>
-            <a:r>
-              <a:rPr lang="en-US" sz="1500" b="1" dirty="0">
-                <a:solidFill>
-                  <a:schemeClr val="tx2"/>
-                </a:solidFill>
-              </a:rPr>
-              <a:t>More voices help even one voice</a:t>
-            </a:r>
-            <a:endParaRPr lang="en-US" sz="1500" dirty="0"/>
-          </a:p>
-        </p:txBody>
-      </p:sp>
-      <p:sp>
-        <p:nvSpPr>
-          <p:cNvPr id="8" name="Text 5"/>
-          <p:cNvSpPr txBox="1"/>
-          <p:nvPr/>
-        </p:nvSpPr>
-        <p:spPr>
-          <a:xfrm>
-            <a:off x="8183880" y="2286000"/>
-            <a:ext cx="3291840" cy="1097280"/>
-          </a:xfrm>
-          <a:prstGeom prst="rect">
-            <a:avLst/>
-          </a:prstGeom>
-          <a:noFill/>
-          <a:ln/>
-        </p:spPr>
-        <p:txBody>
-          <a:bodyPr wrap="square" lIns="0" tIns="0" rIns="0" bIns="0" rtlCol="0" anchor="t"/>
-          <a:lstStyle/>
-          <a:p>
-            <a:pPr marL="0" indent="0">
-              <a:buNone/>
-            </a:pPr>
-            <a:r>
-              <a:rPr lang="en-US" sz="1400" dirty="0">
-                <a:solidFill>
-                  <a:schemeClr val="tx1"/>
-                </a:solidFill>
-              </a:rPr>
-              <a:t>On OpenSLR 42, the ablation's own speaker, ours scores </a:t>
-            </a:r>
-            <a:r>
-              <a:rPr lang="en-US" sz="1400" b="1" dirty="0">
-                <a:solidFill>
-                  <a:schemeClr val="accent3"/>
-                </a:solidFill>
-              </a:rPr>
-              <a:t>12.0%</a:t>
-            </a:r>
-            <a:r>
-              <a:rPr lang="en-US" sz="1400" dirty="0">
-                <a:solidFill>
-                  <a:schemeClr val="tx1"/>
-                </a:solidFill>
-              </a:rPr>
-              <a:t> vs the ablation's </a:t>
-            </a:r>
-            <a:r>
-              <a:rPr lang="en-US" sz="1400" b="1" dirty="0">
-                <a:solidFill>
-                  <a:schemeClr val="accent2"/>
-                </a:solidFill>
-              </a:rPr>
-              <a:t>27.2%</a:t>
-            </a:r>
-            <a:r>
-              <a:rPr lang="en-US" sz="1400" dirty="0">
-                <a:solidFill>
-                  <a:schemeClr val="tx1"/>
-                </a:solidFill>
-              </a:rPr>
-              <a:t>.</a:t>
-            </a:r>
-            <a:endParaRPr lang="en-US" sz="1400" dirty="0"/>
-          </a:p>
-        </p:txBody>
-      </p:sp>
-      <p:sp>
-        <p:nvSpPr>
-          <p:cNvPr id="9" name="insight 2"/>
-          <p:cNvSpPr/>
-          <p:nvPr/>
-        </p:nvSpPr>
-        <p:spPr>
-          <a:xfrm>
-            <a:off x="7955280" y="3703320"/>
-            <a:ext cx="3685032" cy="2286000"/>
-          </a:xfrm>
-          <a:prstGeom prst="roundRect">
-            <a:avLst>
-              <a:gd name="adj" fmla="val 3200"/>
-            </a:avLst>
-          </a:prstGeom>
-          <a:solidFill>
-            <a:schemeClr val="tx2"/>
-          </a:solidFill>
-          <a:ln w="12700">
-            <a:solidFill>
-              <a:schemeClr val="tx2"/>
-            </a:solidFill>
-            <a:prstDash val="solid"/>
-          </a:ln>
-        </p:spPr>
-        <p:txBody>
-          <a:bodyPr/>
-          <a:lstStyle/>
-          <a:p>
-            <a:endParaRPr lang="en-US"/>
-          </a:p>
-        </p:txBody>
-      </p:sp>
-      <p:sp>
-        <p:nvSpPr>
-          <p:cNvPr id="10" name="Text 7"/>
-          <p:cNvSpPr txBox="1"/>
-          <p:nvPr/>
-        </p:nvSpPr>
-        <p:spPr>
-          <a:xfrm>
-            <a:off x="8183880" y="3840480"/>
-            <a:ext cx="3291840" cy="320040"/>
-          </a:xfrm>
-          <a:prstGeom prst="rect">
-            <a:avLst/>
-          </a:prstGeom>
-          <a:noFill/>
-          <a:ln/>
-        </p:spPr>
-        <p:txBody>
-          <a:bodyPr wrap="square" lIns="0" tIns="0" rIns="0" bIns="0" rtlCol="0" anchor="t"/>
-          <a:lstStyle/>
-          <a:p>
-            <a:pPr marL="0" indent="0">
-              <a:buNone/>
-            </a:pPr>
-            <a:r>
-              <a:rPr lang="en-US" sz="1500" b="1" dirty="0">
-                <a:solidFill>
-                  <a:schemeClr val="accent2"/>
-                </a:solidFill>
-              </a:rPr>
-              <a:t>Why test scores worse than ddd_test</a:t>
-            </a:r>
-            <a:endParaRPr lang="en-US" sz="1500" dirty="0"/>
-          </a:p>
-        </p:txBody>
-      </p:sp>
-      <p:sp>
-        <p:nvSpPr>
-          <p:cNvPr id="11" name="Text 8"/>
-          <p:cNvSpPr txBox="1"/>
-          <p:nvPr/>
-        </p:nvSpPr>
-        <p:spPr>
-          <a:xfrm>
-            <a:off x="8183880" y="4206240"/>
-            <a:ext cx="3291840" cy="1691640"/>
-          </a:xfrm>
-          <a:prstGeom prst="rect">
-            <a:avLst/>
-          </a:prstGeom>
-          <a:noFill/>
-          <a:ln/>
-        </p:spPr>
-        <p:txBody>
-          <a:bodyPr wrap="square" lIns="0" tIns="0" rIns="0" bIns="0" rtlCol="0" anchor="t"/>
-          <a:lstStyle/>
-          <a:p>
-            <a:pPr marL="0" indent="0">
-              <a:buNone/>
-            </a:pPr>
-            <a:r>
-              <a:rPr lang="en-US" sz="1400" dirty="0">
-                <a:solidFill>
-                  <a:schemeClr val="bg1"/>
-                </a:solidFill>
-              </a:rPr>
-              <a:t>km-speech-corpus is hardest: ~2.5 s fragments that start or stop mid-sentence. It is 67% of the test split, so test (24.9%) scores worse than ddd_test (18.9%), where sentences are complete.</a:t>
-            </a:r>
-            <a:endParaRPr lang="en-US" sz="1400" dirty="0"/>
-          </a:p>
-        </p:txBody>
-      </p:sp>
-      <p:sp>
-        <p:nvSpPr>
-          <p:cNvPr id="25" name="Slide Number Placeholder 0"/>
-          <p:cNvSpPr>
-            <a:spLocks noGrp="1"/>
-          </p:cNvSpPr>
-          <p:nvPr>
-            <p:ph type="sldNum" sz="quarter" idx="4294967295"/>
-          </p:nvPr>
-        </p:nvSpPr>
-        <p:spPr>
-          <a:xfrm>
-            <a:off x="11183112" y="6400800"/>
-            <a:ext cx="457200" cy="256032"/>
-          </a:xfrm>
-          <a:prstGeom prst="rect">
-            <a:avLst/>
-          </a:prstGeom>
-          <a:extLst>
-            <a:ext uri="{C572A759-6A51-4108-AA02-DFA0A04FC94B}">
-              <ma14:wrappingTextBoxFlag xmlns:ma14="http://schemas.microsoft.com/office/mac/drawingml/2011/main" xmlns="" val="0"/>
-            </a:ext>
-          </a:extLst>
-        </p:spPr>
-        <p:txBody>
-          <a:bodyPr lIns="0" tIns="0" rIns="0" bIns="0"/>
-          <a:lstStyle>
-            <a:lvl1pPr>
-              <a:defRPr sz="1000">
-                <a:solidFill>
-                  <a:schemeClr val="accent5"/>
-                </a:solidFill>
-              </a:defRPr>
-            </a:lvl1pPr>
-          </a:lstStyle>
-          <a:p>
-            <a:pPr algn="r"/>
-            <a:fld id="{F7021451-1387-4CA6-816F-3879F97B5CBC}" type="slidenum">
-              <a:rPr lang="en-US" b="0"/>
-              <a:t>22</a:t>
-            </a:fld>
-            <a:endParaRPr lang="en-US"/>
-          </a:p>
-        </p:txBody>
-      </p:sp>
-    </p:spTree>
-  </p:cSld>
-  <p:clrMapOvr>
-    <a:masterClrMapping/>
-  </p:clrMapOvr>
-</p:sld>
-</file>
-
-<file path=ppt/slides/slide23.xml><?xml version="1.0" encoding="utf-8"?>
-<p:sld xmlns:a="http://schemas.openxmlformats.org/drawingml/2006/main" xmlns:r="http://schemas.openxmlformats.org/officeDocument/2006/relationships" xmlns:p="http://schemas.openxmlformats.org/presentationml/2006/main">
-  <p:cSld name="Slide 23">
-    <p:spTree>
-      <p:nvGrpSpPr>
-        <p:cNvPr id="1" name=""/>
-        <p:cNvGrpSpPr/>
-        <p:nvPr/>
-      </p:nvGrpSpPr>
-      <p:grpSpPr>
-        <a:xfrm>
-          <a:off x="0" y="0"/>
-          <a:ext cx="0" cy="0"/>
-          <a:chOff x="0" y="0"/>
-          <a:chExt cx="0" cy="0"/>
-        </a:xfrm>
-      </p:grpSpPr>
-      <p:sp>
-        <p:nvSpPr>
-          <p:cNvPr id="2" name="Text 0"/>
-          <p:cNvSpPr>
-            <a:spLocks noGrp="1"/>
-          </p:cNvSpPr>
-          <p:nvPr>
-            <p:ph type="body" idx="100" hasCustomPrompt="1"/>
-          </p:nvPr>
-        </p:nvSpPr>
-        <p:spPr>
-          <a:xfrm>
-            <a:off x="548640" y="384048"/>
-            <a:ext cx="11091672" cy="292608"/>
-          </a:xfrm>
-          <a:prstGeom prst="rect">
-            <a:avLst/>
-          </a:prstGeom>
-          <a:noFill/>
-          <a:ln/>
-        </p:spPr>
-        <p:txBody>
-          <a:bodyPr wrap="square" lIns="0" tIns="0" rIns="0" bIns="0" rtlCol="0" anchor="t"/>
-          <a:lstStyle/>
-          <a:p>
-            <a:pPr marL="0" indent="0">
-              <a:buNone/>
-            </a:pPr>
-            <a:r>
-              <a:rPr lang="en-US" sz="1400" b="1" dirty="0">
-                <a:solidFill>
-                  <a:schemeClr val="accent3"/>
-                </a:solidFill>
-              </a:rPr>
-              <a:t>Backup: system architecture</a:t>
-            </a:r>
-            <a:endParaRPr lang="en-US" sz="1400" dirty="0"/>
-          </a:p>
-        </p:txBody>
-      </p:sp>
-      <p:sp>
-        <p:nvSpPr>
-          <p:cNvPr id="3" name="Text 0"/>
-          <p:cNvSpPr>
-            <a:spLocks noGrp="1"/>
-          </p:cNvSpPr>
-          <p:nvPr>
-            <p:ph type="title" idx="101" hasCustomPrompt="1"/>
-          </p:nvPr>
-        </p:nvSpPr>
-        <p:spPr>
-          <a:xfrm>
-            <a:off x="548640" y="713232"/>
-            <a:ext cx="11091672" cy="685800"/>
-          </a:xfrm>
-          <a:prstGeom prst="rect">
-            <a:avLst/>
-          </a:prstGeom>
-          <a:noFill/>
-          <a:ln/>
-        </p:spPr>
-        <p:txBody>
-          <a:bodyPr wrap="square" lIns="0" tIns="0" rIns="0" bIns="0" rtlCol="0" anchor="t"/>
-          <a:lstStyle/>
-          <a:p>
-            <a:pPr marL="0" indent="0" algn="l">
-              <a:buNone/>
-            </a:pPr>
-            <a:r>
-              <a:rPr lang="en-US" sz="3200" b="1" dirty="0">
-                <a:solidFill>
-                  <a:schemeClr val="tx2"/>
-                </a:solidFill>
-                <a:latin typeface="Calibri" pitchFamily="34" charset="0"/>
-                <a:ea typeface="Calibri" pitchFamily="34" charset="-122"/>
-                <a:cs typeface="Calibri" pitchFamily="34" charset="-120"/>
-              </a:rPr>
-              <a:t>Inside the back end: from a </a:t>
-            </a:r>
-            <a:r>
-              <a:rPr lang="en-US" sz="3200" b="1" dirty="0">
-                <a:solidFill>
-                  <a:schemeClr val="accent3"/>
-                </a:solidFill>
-                <a:latin typeface="Calibri" pitchFamily="34" charset="0"/>
-                <a:ea typeface="Calibri" pitchFamily="34" charset="-122"/>
-                <a:cs typeface="Calibri" pitchFamily="34" charset="-120"/>
-              </a:rPr>
-              <a:t>YouTube link</a:t>
-            </a:r>
-            <a:r>
-              <a:rPr lang="en-US" sz="3200" b="1" dirty="0">
-                <a:solidFill>
-                  <a:schemeClr val="tx2"/>
-                </a:solidFill>
-                <a:latin typeface="Calibri" pitchFamily="34" charset="0"/>
-                <a:ea typeface="Calibri" pitchFamily="34" charset="-122"/>
-                <a:cs typeface="Calibri" pitchFamily="34" charset="-120"/>
-              </a:rPr>
-              <a:t> to subtitles</a:t>
-            </a:r>
-            <a:endParaRPr lang="en-US" sz="3200" dirty="0"/>
-          </a:p>
-        </p:txBody>
-      </p:sp>
-      <p:sp>
-        <p:nvSpPr>
-          <p:cNvPr id="4" name="Download step"/>
-          <p:cNvSpPr/>
-          <p:nvPr/>
-        </p:nvSpPr>
-        <p:spPr>
-          <a:xfrm>
-            <a:off x="548640" y="1828800"/>
-            <a:ext cx="2606040" cy="2057400"/>
-          </a:xfrm>
-          <a:prstGeom prst="roundRect">
-            <a:avLst>
-              <a:gd name="adj" fmla="val 3556"/>
-            </a:avLst>
-          </a:prstGeom>
-          <a:solidFill>
-            <a:schemeClr val="bg1"/>
-          </a:solidFill>
-          <a:ln w="15875">
-            <a:solidFill>
-              <a:schemeClr val="accent6"/>
-            </a:solidFill>
-            <a:prstDash val="solid"/>
-          </a:ln>
-        </p:spPr>
-        <p:txBody>
-          <a:bodyPr/>
-          <a:lstStyle/>
-          <a:p>
-            <a:endParaRPr lang="en-US"/>
-          </a:p>
-        </p:txBody>
-      </p:sp>
-      <p:sp>
-        <p:nvSpPr>
-          <p:cNvPr id="5" name="Text 3"/>
-          <p:cNvSpPr txBox="1"/>
-          <p:nvPr/>
-        </p:nvSpPr>
-        <p:spPr>
-          <a:xfrm>
-            <a:off x="777240" y="1965960"/>
-            <a:ext cx="914400" cy="502920"/>
-          </a:xfrm>
-          <a:prstGeom prst="rect">
-            <a:avLst/>
-          </a:prstGeom>
-          <a:noFill/>
-          <a:ln/>
-        </p:spPr>
-        <p:txBody>
-          <a:bodyPr wrap="square" lIns="0" tIns="0" rIns="0" bIns="0" rtlCol="0" anchor="t"/>
-          <a:lstStyle/>
-          <a:p>
-            <a:pPr marL="0" indent="0">
-              <a:buNone/>
-            </a:pPr>
-            <a:r>
-              <a:rPr lang="en-US" sz="3000" b="1" dirty="0">
-                <a:solidFill>
-                  <a:schemeClr val="accent2"/>
-                </a:solidFill>
-              </a:rPr>
-              <a:t>1</a:t>
-            </a:r>
-            <a:endParaRPr lang="en-US" sz="3000" dirty="0"/>
-          </a:p>
-        </p:txBody>
-      </p:sp>
-      <p:sp>
-        <p:nvSpPr>
-          <p:cNvPr id="6" name="Text 4"/>
-          <p:cNvSpPr txBox="1"/>
-          <p:nvPr/>
-        </p:nvSpPr>
-        <p:spPr>
-          <a:xfrm>
-            <a:off x="777240" y="2514600"/>
-            <a:ext cx="2194560" cy="365760"/>
-          </a:xfrm>
-          <a:prstGeom prst="rect">
-            <a:avLst/>
-          </a:prstGeom>
-          <a:noFill/>
-          <a:ln/>
-        </p:spPr>
-        <p:txBody>
-          <a:bodyPr wrap="square" lIns="0" tIns="0" rIns="0" bIns="0" rtlCol="0" anchor="t"/>
-          <a:lstStyle/>
-          <a:p>
-            <a:pPr marL="0" indent="0">
-              <a:buNone/>
-            </a:pPr>
-            <a:r>
-              <a:rPr lang="en-US" sz="1800" b="1" dirty="0">
-                <a:solidFill>
-                  <a:schemeClr val="tx2"/>
-                </a:solidFill>
-              </a:rPr>
-              <a:t>Download</a:t>
-            </a:r>
-            <a:endParaRPr lang="en-US" sz="1800" dirty="0"/>
-          </a:p>
-        </p:txBody>
-      </p:sp>
-      <p:sp>
-        <p:nvSpPr>
-          <p:cNvPr id="7" name="Text 5"/>
-          <p:cNvSpPr txBox="1"/>
-          <p:nvPr/>
-        </p:nvSpPr>
-        <p:spPr>
-          <a:xfrm>
-            <a:off x="777240" y="2907792"/>
-            <a:ext cx="2194560" cy="868680"/>
-          </a:xfrm>
-          <a:prstGeom prst="rect">
-            <a:avLst/>
-          </a:prstGeom>
-          <a:noFill/>
-          <a:ln/>
-        </p:spPr>
-        <p:txBody>
-          <a:bodyPr wrap="square" lIns="0" tIns="0" rIns="0" bIns="0" rtlCol="0" anchor="t"/>
-          <a:lstStyle/>
-          <a:p>
-            <a:pPr marL="0" indent="0">
-              <a:buNone/>
-            </a:pPr>
-            <a:r>
-              <a:rPr lang="en-US" sz="1400" dirty="0">
-                <a:solidFill>
-                  <a:schemeClr val="tx1"/>
-                </a:solidFill>
-              </a:rPr>
-              <a:t>yt-dlp and ffmpeg fetch the audio as 16 kHz mono.</a:t>
-            </a:r>
-            <a:endParaRPr lang="en-US" sz="1400" dirty="0"/>
-          </a:p>
-        </p:txBody>
-      </p:sp>
-      <p:sp>
-        <p:nvSpPr>
-          <p:cNvPr id="8" name="arrow"/>
-          <p:cNvSpPr/>
-          <p:nvPr/>
-        </p:nvSpPr>
-        <p:spPr>
-          <a:xfrm>
-            <a:off x="3182112" y="2852928"/>
-            <a:ext cx="182880" cy="0"/>
-          </a:xfrm>
-          <a:prstGeom prst="line">
-            <a:avLst/>
-          </a:prstGeom>
-          <a:noFill/>
-          <a:ln w="19050">
-            <a:solidFill>
-              <a:schemeClr val="accent5"/>
-            </a:solidFill>
-            <a:prstDash val="solid"/>
-            <a:tailEnd type="triangle"/>
-          </a:ln>
-        </p:spPr>
-        <p:txBody>
-          <a:bodyPr/>
-          <a:lstStyle/>
-          <a:p>
-            <a:endParaRPr lang="en-US"/>
-          </a:p>
-        </p:txBody>
-      </p:sp>
-      <p:sp>
-        <p:nvSpPr>
-          <p:cNvPr id="9" name="Split at pauses step"/>
-          <p:cNvSpPr/>
-          <p:nvPr/>
-        </p:nvSpPr>
-        <p:spPr>
-          <a:xfrm>
-            <a:off x="3392424" y="1828800"/>
-            <a:ext cx="2606040" cy="2057400"/>
-          </a:xfrm>
-          <a:prstGeom prst="roundRect">
-            <a:avLst>
-              <a:gd name="adj" fmla="val 3556"/>
-            </a:avLst>
-          </a:prstGeom>
-          <a:solidFill>
-            <a:schemeClr val="bg1"/>
-          </a:solidFill>
-          <a:ln w="15875">
-            <a:solidFill>
-              <a:schemeClr val="accent6"/>
-            </a:solidFill>
-            <a:prstDash val="solid"/>
-          </a:ln>
-        </p:spPr>
-        <p:txBody>
-          <a:bodyPr/>
-          <a:lstStyle/>
-          <a:p>
-            <a:endParaRPr lang="en-US"/>
-          </a:p>
-        </p:txBody>
-      </p:sp>
-      <p:sp>
-        <p:nvSpPr>
-          <p:cNvPr id="10" name="Text 8"/>
-          <p:cNvSpPr txBox="1"/>
-          <p:nvPr/>
-        </p:nvSpPr>
-        <p:spPr>
-          <a:xfrm>
-            <a:off x="3621024" y="1965960"/>
-            <a:ext cx="914400" cy="502920"/>
-          </a:xfrm>
-          <a:prstGeom prst="rect">
-            <a:avLst/>
-          </a:prstGeom>
-          <a:noFill/>
-          <a:ln/>
-        </p:spPr>
-        <p:txBody>
-          <a:bodyPr wrap="square" lIns="0" tIns="0" rIns="0" bIns="0" rtlCol="0" anchor="t"/>
-          <a:lstStyle/>
-          <a:p>
-            <a:pPr marL="0" indent="0">
-              <a:buNone/>
-            </a:pPr>
-            <a:r>
-              <a:rPr lang="en-US" sz="3000" b="1" dirty="0">
-                <a:solidFill>
-                  <a:schemeClr val="accent2"/>
-                </a:solidFill>
-              </a:rPr>
-              <a:t>2</a:t>
-            </a:r>
-            <a:endParaRPr lang="en-US" sz="3000" dirty="0"/>
-          </a:p>
-        </p:txBody>
-      </p:sp>
-      <p:sp>
-        <p:nvSpPr>
-          <p:cNvPr id="11" name="Text 9"/>
-          <p:cNvSpPr txBox="1"/>
-          <p:nvPr/>
-        </p:nvSpPr>
-        <p:spPr>
-          <a:xfrm>
-            <a:off x="3621024" y="2514600"/>
-            <a:ext cx="2194560" cy="365760"/>
-          </a:xfrm>
-          <a:prstGeom prst="rect">
-            <a:avLst/>
-          </a:prstGeom>
-          <a:noFill/>
-          <a:ln/>
-        </p:spPr>
-        <p:txBody>
-          <a:bodyPr wrap="square" lIns="0" tIns="0" rIns="0" bIns="0" rtlCol="0" anchor="t"/>
-          <a:lstStyle/>
-          <a:p>
-            <a:pPr marL="0" indent="0">
-              <a:buNone/>
-            </a:pPr>
-            <a:r>
-              <a:rPr lang="en-US" sz="1800" b="1" dirty="0">
-                <a:solidFill>
-                  <a:schemeClr val="tx2"/>
-                </a:solidFill>
-              </a:rPr>
-              <a:t>Split at pauses</a:t>
-            </a:r>
-            <a:endParaRPr lang="en-US" sz="1800" dirty="0"/>
-          </a:p>
-        </p:txBody>
-      </p:sp>
-      <p:sp>
-        <p:nvSpPr>
-          <p:cNvPr id="12" name="Text 10"/>
-          <p:cNvSpPr txBox="1"/>
-          <p:nvPr/>
-        </p:nvSpPr>
-        <p:spPr>
-          <a:xfrm>
-            <a:off x="3621024" y="2907792"/>
-            <a:ext cx="2194560" cy="868680"/>
-          </a:xfrm>
-          <a:prstGeom prst="rect">
-            <a:avLst/>
-          </a:prstGeom>
-          <a:noFill/>
-          <a:ln/>
-        </p:spPr>
-        <p:txBody>
-          <a:bodyPr wrap="square" lIns="0" tIns="0" rIns="0" bIns="0" rtlCol="0" anchor="t"/>
-          <a:lstStyle/>
-          <a:p>
-            <a:pPr marL="0" indent="0">
-              <a:buNone/>
-            </a:pPr>
-            <a:r>
-              <a:rPr lang="en-US" sz="1400" dirty="0">
-                <a:solidFill>
-                  <a:schemeClr val="tx1"/>
-                </a:solidFill>
-              </a:rPr>
-              <a:t>Chunks of 10 s or less, cut at silences. Silent chunks are skipped.</a:t>
-            </a:r>
-            <a:endParaRPr lang="en-US" sz="1400" dirty="0"/>
-          </a:p>
-        </p:txBody>
-      </p:sp>
-      <p:sp>
-        <p:nvSpPr>
-          <p:cNvPr id="13" name="arrow"/>
-          <p:cNvSpPr/>
-          <p:nvPr/>
-        </p:nvSpPr>
-        <p:spPr>
-          <a:xfrm>
-            <a:off x="6025896" y="2852928"/>
-            <a:ext cx="182880" cy="0"/>
-          </a:xfrm>
-          <a:prstGeom prst="line">
-            <a:avLst/>
-          </a:prstGeom>
-          <a:noFill/>
-          <a:ln w="19050">
-            <a:solidFill>
-              <a:schemeClr val="accent5"/>
-            </a:solidFill>
-            <a:prstDash val="solid"/>
-            <a:tailEnd type="triangle"/>
-          </a:ln>
-        </p:spPr>
-        <p:txBody>
-          <a:bodyPr/>
-          <a:lstStyle/>
-          <a:p>
-            <a:endParaRPr lang="en-US"/>
-          </a:p>
-        </p:txBody>
-      </p:sp>
-      <p:sp>
-        <p:nvSpPr>
-          <p:cNvPr id="14" name="Transcribe step"/>
-          <p:cNvSpPr/>
-          <p:nvPr/>
-        </p:nvSpPr>
-        <p:spPr>
-          <a:xfrm>
-            <a:off x="6236208" y="1828800"/>
-            <a:ext cx="2606040" cy="2057400"/>
-          </a:xfrm>
-          <a:prstGeom prst="roundRect">
-            <a:avLst>
-              <a:gd name="adj" fmla="val 3556"/>
-            </a:avLst>
-          </a:prstGeom>
-          <a:solidFill>
-            <a:schemeClr val="bg1"/>
-          </a:solidFill>
-          <a:ln w="15875">
-            <a:solidFill>
-              <a:schemeClr val="accent6"/>
-            </a:solidFill>
-            <a:prstDash val="solid"/>
-          </a:ln>
-        </p:spPr>
-        <p:txBody>
-          <a:bodyPr/>
-          <a:lstStyle/>
-          <a:p>
-            <a:endParaRPr lang="en-US"/>
-          </a:p>
-        </p:txBody>
-      </p:sp>
-      <p:sp>
-        <p:nvSpPr>
-          <p:cNvPr id="15" name="Text 13"/>
-          <p:cNvSpPr txBox="1"/>
-          <p:nvPr/>
-        </p:nvSpPr>
-        <p:spPr>
-          <a:xfrm>
-            <a:off x="6464808" y="1965960"/>
-            <a:ext cx="914400" cy="502920"/>
-          </a:xfrm>
-          <a:prstGeom prst="rect">
-            <a:avLst/>
-          </a:prstGeom>
-          <a:noFill/>
-          <a:ln/>
-        </p:spPr>
-        <p:txBody>
-          <a:bodyPr wrap="square" lIns="0" tIns="0" rIns="0" bIns="0" rtlCol="0" anchor="t"/>
-          <a:lstStyle/>
-          <a:p>
-            <a:pPr marL="0" indent="0">
-              <a:buNone/>
-            </a:pPr>
-            <a:r>
-              <a:rPr lang="en-US" sz="3000" b="1" dirty="0">
-                <a:solidFill>
-                  <a:schemeClr val="accent2"/>
-                </a:solidFill>
-              </a:rPr>
-              <a:t>3</a:t>
-            </a:r>
-            <a:endParaRPr lang="en-US" sz="3000" dirty="0"/>
-          </a:p>
-        </p:txBody>
-      </p:sp>
-      <p:sp>
-        <p:nvSpPr>
-          <p:cNvPr id="16" name="Text 14"/>
-          <p:cNvSpPr txBox="1"/>
-          <p:nvPr/>
-        </p:nvSpPr>
-        <p:spPr>
-          <a:xfrm>
-            <a:off x="6464808" y="2514600"/>
-            <a:ext cx="2194560" cy="365760"/>
-          </a:xfrm>
-          <a:prstGeom prst="rect">
-            <a:avLst/>
-          </a:prstGeom>
-          <a:noFill/>
-          <a:ln/>
-        </p:spPr>
-        <p:txBody>
-          <a:bodyPr wrap="square" lIns="0" tIns="0" rIns="0" bIns="0" rtlCol="0" anchor="t"/>
-          <a:lstStyle/>
-          <a:p>
-            <a:pPr marL="0" indent="0">
-              <a:buNone/>
-            </a:pPr>
-            <a:r>
-              <a:rPr lang="en-US" sz="1800" b="1" dirty="0">
-                <a:solidFill>
-                  <a:schemeClr val="tx2"/>
-                </a:solidFill>
-              </a:rPr>
-              <a:t>Transcribe</a:t>
-            </a:r>
-            <a:endParaRPr lang="en-US" sz="1800" dirty="0"/>
-          </a:p>
-        </p:txBody>
-      </p:sp>
-      <p:sp>
-        <p:nvSpPr>
-          <p:cNvPr id="17" name="Text 15"/>
-          <p:cNvSpPr txBox="1"/>
-          <p:nvPr/>
-        </p:nvSpPr>
-        <p:spPr>
-          <a:xfrm>
-            <a:off x="6464808" y="2907792"/>
-            <a:ext cx="2194560" cy="868680"/>
-          </a:xfrm>
-          <a:prstGeom prst="rect">
-            <a:avLst/>
-          </a:prstGeom>
-          <a:noFill/>
-          <a:ln/>
-        </p:spPr>
-        <p:txBody>
-          <a:bodyPr wrap="square" lIns="0" tIns="0" rIns="0" bIns="0" rtlCol="0" anchor="t"/>
-          <a:lstStyle/>
-          <a:p>
-            <a:pPr marL="0" indent="0">
-              <a:buNone/>
-            </a:pPr>
-            <a:r>
-              <a:rPr lang="en-US" sz="1400" dirty="0">
-                <a:solidFill>
-                  <a:schemeClr val="tx1"/>
-                </a:solidFill>
-              </a:rPr>
-              <a:t>8 chunks per batch, fp16 on GPU, with timestamps: 2.5× faster.</a:t>
-            </a:r>
-            <a:endParaRPr lang="en-US" sz="1400" dirty="0"/>
-          </a:p>
-        </p:txBody>
-      </p:sp>
-      <p:sp>
-        <p:nvSpPr>
-          <p:cNvPr id="18" name="arrow"/>
-          <p:cNvSpPr/>
-          <p:nvPr/>
-        </p:nvSpPr>
-        <p:spPr>
-          <a:xfrm>
-            <a:off x="8869680" y="2852928"/>
-            <a:ext cx="182880" cy="0"/>
-          </a:xfrm>
-          <a:prstGeom prst="line">
-            <a:avLst/>
-          </a:prstGeom>
-          <a:noFill/>
-          <a:ln w="19050">
-            <a:solidFill>
-              <a:schemeClr val="accent5"/>
-            </a:solidFill>
-            <a:prstDash val="solid"/>
-            <a:tailEnd type="triangle"/>
-          </a:ln>
-        </p:spPr>
-        <p:txBody>
-          <a:bodyPr/>
-          <a:lstStyle/>
-          <a:p>
-            <a:endParaRPr lang="en-US"/>
-          </a:p>
-        </p:txBody>
-      </p:sp>
-      <p:sp>
-        <p:nvSpPr>
-          <p:cNvPr id="19" name="Assemble step"/>
-          <p:cNvSpPr/>
-          <p:nvPr/>
-        </p:nvSpPr>
-        <p:spPr>
-          <a:xfrm>
-            <a:off x="9079992" y="1828800"/>
-            <a:ext cx="2606040" cy="2057400"/>
-          </a:xfrm>
-          <a:prstGeom prst="roundRect">
-            <a:avLst>
-              <a:gd name="adj" fmla="val 3556"/>
-            </a:avLst>
-          </a:prstGeom>
-          <a:solidFill>
-            <a:schemeClr val="bg1"/>
-          </a:solidFill>
-          <a:ln w="15875">
-            <a:solidFill>
-              <a:schemeClr val="accent6"/>
-            </a:solidFill>
-            <a:prstDash val="solid"/>
-          </a:ln>
-        </p:spPr>
-        <p:txBody>
-          <a:bodyPr/>
-          <a:lstStyle/>
-          <a:p>
-            <a:endParaRPr lang="en-US"/>
-          </a:p>
-        </p:txBody>
-      </p:sp>
-      <p:sp>
-        <p:nvSpPr>
-          <p:cNvPr id="20" name="Text 18"/>
-          <p:cNvSpPr txBox="1"/>
-          <p:nvPr/>
-        </p:nvSpPr>
-        <p:spPr>
-          <a:xfrm>
-            <a:off x="9308592" y="1965960"/>
-            <a:ext cx="914400" cy="502920"/>
-          </a:xfrm>
-          <a:prstGeom prst="rect">
-            <a:avLst/>
-          </a:prstGeom>
-          <a:noFill/>
-          <a:ln/>
-        </p:spPr>
-        <p:txBody>
-          <a:bodyPr wrap="square" lIns="0" tIns="0" rIns="0" bIns="0" rtlCol="0" anchor="t"/>
-          <a:lstStyle/>
-          <a:p>
-            <a:pPr marL="0" indent="0">
-              <a:buNone/>
-            </a:pPr>
-            <a:r>
-              <a:rPr lang="en-US" sz="3000" b="1" dirty="0">
-                <a:solidFill>
-                  <a:schemeClr val="accent2"/>
-                </a:solidFill>
-              </a:rPr>
-              <a:t>4</a:t>
-            </a:r>
-            <a:endParaRPr lang="en-US" sz="3000" dirty="0"/>
-          </a:p>
-        </p:txBody>
-      </p:sp>
-      <p:sp>
-        <p:nvSpPr>
-          <p:cNvPr id="21" name="Text 19"/>
-          <p:cNvSpPr txBox="1"/>
-          <p:nvPr/>
-        </p:nvSpPr>
-        <p:spPr>
-          <a:xfrm>
-            <a:off x="9308592" y="2514600"/>
-            <a:ext cx="2194560" cy="365760"/>
-          </a:xfrm>
-          <a:prstGeom prst="rect">
-            <a:avLst/>
-          </a:prstGeom>
-          <a:noFill/>
-          <a:ln/>
-        </p:spPr>
-        <p:txBody>
-          <a:bodyPr wrap="square" lIns="0" tIns="0" rIns="0" bIns="0" rtlCol="0" anchor="t"/>
-          <a:lstStyle/>
-          <a:p>
-            <a:pPr marL="0" indent="0">
-              <a:buNone/>
-            </a:pPr>
-            <a:r>
-              <a:rPr lang="en-US" sz="1800" b="1" dirty="0">
-                <a:solidFill>
-                  <a:schemeClr val="tx2"/>
-                </a:solidFill>
-              </a:rPr>
-              <a:t>Assemble</a:t>
-            </a:r>
-            <a:endParaRPr lang="en-US" sz="1800" dirty="0"/>
-          </a:p>
-        </p:txBody>
-      </p:sp>
-      <p:sp>
-        <p:nvSpPr>
-          <p:cNvPr id="22" name="Text 20"/>
-          <p:cNvSpPr txBox="1"/>
-          <p:nvPr/>
-        </p:nvSpPr>
-        <p:spPr>
-          <a:xfrm>
-            <a:off x="9308592" y="2907792"/>
-            <a:ext cx="2194560" cy="868680"/>
-          </a:xfrm>
-          <a:prstGeom prst="rect">
-            <a:avLst/>
-          </a:prstGeom>
-          <a:noFill/>
-          <a:ln/>
-        </p:spPr>
-        <p:txBody>
-          <a:bodyPr wrap="square" lIns="0" tIns="0" rIns="0" bIns="0" rtlCol="0" anchor="t"/>
-          <a:lstStyle/>
-          <a:p>
-            <a:pPr marL="0" indent="0">
-              <a:buNone/>
-            </a:pPr>
-            <a:r>
-              <a:rPr lang="en-US" sz="1400" dirty="0">
-                <a:solidFill>
-                  <a:schemeClr val="tx1"/>
-                </a:solidFill>
-              </a:rPr>
-              <a:t>Shift times by each chunk's start: (start, end, text) segments.</a:t>
-            </a:r>
-            <a:endParaRPr lang="en-US" sz="1400" dirty="0"/>
-          </a:p>
-        </p:txBody>
-      </p:sp>
-      <p:sp>
-        <p:nvSpPr>
-          <p:cNvPr id="23" name="why 10 s chunks"/>
-          <p:cNvSpPr/>
-          <p:nvPr/>
-        </p:nvSpPr>
-        <p:spPr>
-          <a:xfrm>
-            <a:off x="548640" y="4206240"/>
-            <a:ext cx="11091672" cy="1417320"/>
-          </a:xfrm>
-          <a:prstGeom prst="roundRect">
-            <a:avLst>
-              <a:gd name="adj" fmla="val 5161"/>
-            </a:avLst>
-          </a:prstGeom>
-          <a:solidFill>
-            <a:schemeClr val="tx2"/>
-          </a:solidFill>
-          <a:ln w="12700">
-            <a:solidFill>
-              <a:schemeClr val="tx2"/>
-            </a:solidFill>
-            <a:prstDash val="solid"/>
-          </a:ln>
-        </p:spPr>
-        <p:txBody>
-          <a:bodyPr/>
-          <a:lstStyle/>
-          <a:p>
-            <a:endParaRPr lang="en-US"/>
-          </a:p>
-        </p:txBody>
-      </p:sp>
-      <p:sp>
-        <p:nvSpPr>
-          <p:cNvPr id="24" name="Text 22"/>
-          <p:cNvSpPr txBox="1"/>
-          <p:nvPr/>
-        </p:nvSpPr>
-        <p:spPr>
-          <a:xfrm>
-            <a:off x="868680" y="4343400"/>
-            <a:ext cx="5486400" cy="320040"/>
-          </a:xfrm>
-          <a:prstGeom prst="rect">
-            <a:avLst/>
-          </a:prstGeom>
-          <a:noFill/>
-          <a:ln/>
-        </p:spPr>
-        <p:txBody>
-          <a:bodyPr wrap="square" lIns="0" tIns="0" rIns="0" bIns="0" rtlCol="0" anchor="t"/>
-          <a:lstStyle/>
-          <a:p>
-            <a:pPr marL="0" indent="0">
-              <a:buNone/>
-            </a:pPr>
-            <a:r>
-              <a:rPr lang="en-US" sz="1500" b="1" dirty="0">
-                <a:solidFill>
-                  <a:schemeClr val="accent2"/>
-                </a:solidFill>
-              </a:rPr>
-              <a:t>Why 10-second chunks?</a:t>
-            </a:r>
-            <a:endParaRPr lang="en-US" sz="1500" dirty="0"/>
-          </a:p>
-        </p:txBody>
-      </p:sp>
-      <p:sp>
-        <p:nvSpPr>
-          <p:cNvPr id="25" name="Text 23"/>
-          <p:cNvSpPr txBox="1"/>
-          <p:nvPr/>
-        </p:nvSpPr>
-        <p:spPr>
-          <a:xfrm>
-            <a:off x="868680" y="4709160"/>
-            <a:ext cx="10469880" cy="777240"/>
-          </a:xfrm>
-          <a:prstGeom prst="rect">
-            <a:avLst/>
-          </a:prstGeom>
-          <a:noFill/>
-          <a:ln/>
-        </p:spPr>
-        <p:txBody>
-          <a:bodyPr wrap="square" lIns="0" tIns="0" rIns="0" bIns="0" rtlCol="0" anchor="t"/>
-          <a:lstStyle/>
-          <a:p>
-            <a:pPr marL="0" indent="0">
-              <a:buNone/>
-            </a:pPr>
-            <a:r>
-              <a:rPr lang="en-US" sz="1600" dirty="0">
-                <a:solidFill>
-                  <a:schemeClr val="bg1"/>
-                </a:solidFill>
-              </a:rPr>
-              <a:t>Khmer needs about 400 Whisper tokens per 15 s of read speech, and the decoder stops at 448 (section 6). With 15 s chunks, the ends of fast sentences came out garbled; 10 s chunks fixed it.</a:t>
-            </a:r>
-            <a:endParaRPr lang="en-US" sz="1600" dirty="0"/>
-          </a:p>
-        </p:txBody>
-      </p:sp>
-      <p:sp>
-        <p:nvSpPr>
-          <p:cNvPr id="26" name="Slide Number Placeholder 0"/>
-          <p:cNvSpPr>
-            <a:spLocks noGrp="1"/>
-          </p:cNvSpPr>
-          <p:nvPr>
-            <p:ph type="sldNum" sz="quarter" idx="4294967295"/>
-          </p:nvPr>
-        </p:nvSpPr>
-        <p:spPr>
-          <a:xfrm>
-            <a:off x="11183112" y="6400800"/>
-            <a:ext cx="457200" cy="256032"/>
-          </a:xfrm>
-          <a:prstGeom prst="rect">
-            <a:avLst/>
-          </a:prstGeom>
-          <a:extLst>
-            <a:ext uri="{C572A759-6A51-4108-AA02-DFA0A04FC94B}">
-              <ma14:wrappingTextBoxFlag xmlns:ma14="http://schemas.microsoft.com/office/mac/drawingml/2011/main" xmlns="" val="0"/>
-            </a:ext>
-          </a:extLst>
-        </p:spPr>
-        <p:txBody>
-          <a:bodyPr lIns="0" tIns="0" rIns="0" bIns="0"/>
-          <a:lstStyle>
-            <a:lvl1pPr>
-              <a:defRPr sz="1000">
-                <a:solidFill>
-                  <a:schemeClr val="accent5"/>
-                </a:solidFill>
-              </a:defRPr>
-            </a:lvl1pPr>
-          </a:lstStyle>
-          <a:p>
-            <a:pPr algn="r"/>
-            <a:fld id="{F7021451-1387-4CA6-816F-3879F97B5CBC}" type="slidenum">
-              <a:rPr lang="en-US" b="0"/>
-              <a:t>23</a:t>
-            </a:fld>
-            <a:endParaRPr lang="en-US"/>
-          </a:p>
-        </p:txBody>
-      </p:sp>
-    </p:spTree>
-  </p:cSld>
-  <p:clrMapOvr>
-    <a:masterClrMapping/>
-  </p:clrMapOvr>
-</p:sld>
-</file>
-
-<file path=ppt/slides/slide24.xml><?xml version="1.0" encoding="utf-8"?>
-<p:sld xmlns:a="http://schemas.openxmlformats.org/drawingml/2006/main" xmlns:r="http://schemas.openxmlformats.org/officeDocument/2006/relationships" xmlns:p="http://schemas.openxmlformats.org/presentationml/2006/main">
   <p:cSld name="Slide 24">
     <p:spTree>
       <p:nvGrpSpPr>
@@ -26548,7 +23501,7 @@
             <a:pPr algn="r"/>
             <a:fld id="{F7021451-1387-4CA6-816F-3879F97B5CBC}" type="slidenum">
               <a:rPr lang="en-US" b="0"/>
-              <a:t>24</a:t>
+              <a:t>22</a:t>
             </a:fld>
             <a:endParaRPr lang="en-US"/>
           </a:p>
@@ -27942,7 +24895,7 @@
         </p:nvGraphicFramePr>
         <p:xfrm>
           <a:off x="548640" y="1783080"/>
-          <a:ext cx="11091672" cy="914400"/>
+          <a:ext cx="11091672" cy="2697480"/>
         </p:xfrm>
         <a:graphic>
           <a:graphicData uri="http://schemas.openxmlformats.org/drawingml/2006/table">

</xml_diff>